<commit_message>
Update profile and handoff artifacts
</commit_message>
<xml_diff>
--- a/reports/uArcSim Implementation by AI.pptx
+++ b/reports/uArcSim Implementation by AI.pptx
@@ -15,9 +15,10 @@
     <p:sldId id="267" r:id="rId9"/>
     <p:sldId id="261" r:id="rId10"/>
     <p:sldId id="262" r:id="rId11"/>
-    <p:sldId id="263" r:id="rId12"/>
-    <p:sldId id="264" r:id="rId13"/>
-    <p:sldId id="269" r:id="rId14"/>
+    <p:sldId id="270" r:id="rId12"/>
+    <p:sldId id="271" r:id="rId13"/>
+    <p:sldId id="263" r:id="rId14"/>
+    <p:sldId id="269" r:id="rId15"/>
   </p:sldIdLst>
   <p:sldSz cx="12192000" cy="6858000"/>
   <p:notesSz cx="7559675" cy="10691813"/>
@@ -1655,7 +1656,7 @@
           <a:p>
             <a:fld id="{5BCAD085-E8A6-8845-BD4E-CB4CCA059FC4}" type="datetimeFigureOut">
               <a:rPr lang="en-US" smtClean="0"/>
-              <a:t>5/10/26</a:t>
+              <a:t>5/11/26</a:t>
             </a:fld>
             <a:endParaRPr lang="en-US"/>
           </a:p>
@@ -7647,7 +7648,7 @@
               </a:lnSpc>
             </a:pPr>
             <a:r>
-              <a:rPr lang="en-US" sz="2600" b="1" u="none" strike="noStrike">
+              <a:rPr lang="en-US" sz="2600" b="1" u="none" strike="noStrike" dirty="0">
                 <a:solidFill>
                   <a:srgbClr val="183458"/>
                 </a:solidFill>
@@ -7657,7 +7658,7 @@
               </a:rPr>
               <a:t>Regression Table &amp; L1Mesh Evaluation </a:t>
             </a:r>
-            <a:endParaRPr lang="en-US" sz="2600" b="0" u="none" strike="noStrike">
+            <a:endParaRPr lang="en-US" sz="2600" b="0" u="none" strike="noStrike" dirty="0">
               <a:solidFill>
                 <a:srgbClr val="000000"/>
               </a:solidFill>
@@ -7939,6 +7940,733 @@
           <a:chExt cx="0" cy="0"/>
         </a:xfrm>
       </p:grpSpPr>
+      <p:pic>
+        <p:nvPicPr>
+          <p:cNvPr id="4" name="圖片 3">
+            <a:extLst>
+              <a:ext uri="{FF2B5EF4-FFF2-40B4-BE49-F238E27FC236}">
+                <a16:creationId xmlns:a16="http://schemas.microsoft.com/office/drawing/2014/main" id="{05BCAE66-AA2A-9B6B-1CC9-3EB745DF5952}"/>
+              </a:ext>
+            </a:extLst>
+          </p:cNvPr>
+          <p:cNvPicPr>
+            <a:picLocks noChangeAspect="1"/>
+          </p:cNvPicPr>
+          <p:nvPr/>
+        </p:nvPicPr>
+        <p:blipFill>
+          <a:blip r:embed="rId2">
+            <a:extLst>
+              <a:ext uri="{28A0092B-C50C-407E-A947-70E740481C1C}">
+                <a14:useLocalDpi xmlns:a14="http://schemas.microsoft.com/office/drawing/2010/main" val="0"/>
+              </a:ext>
+            </a:extLst>
+          </a:blip>
+          <a:srcRect t="7413" b="13056"/>
+          <a:stretch>
+            <a:fillRect/>
+          </a:stretch>
+        </p:blipFill>
+        <p:spPr>
+          <a:xfrm>
+            <a:off x="104466" y="2257269"/>
+            <a:ext cx="11653014" cy="4526708"/>
+          </a:xfrm>
+          <a:prstGeom prst="rect">
+            <a:avLst/>
+          </a:prstGeom>
+        </p:spPr>
+      </p:pic>
+      <p:sp>
+        <p:nvSpPr>
+          <p:cNvPr id="2" name="標題 1">
+            <a:extLst>
+              <a:ext uri="{FF2B5EF4-FFF2-40B4-BE49-F238E27FC236}">
+                <a16:creationId xmlns:a16="http://schemas.microsoft.com/office/drawing/2014/main" id="{014ED936-4930-E8C0-7660-BEE700C50ACA}"/>
+              </a:ext>
+            </a:extLst>
+          </p:cNvPr>
+          <p:cNvSpPr>
+            <a:spLocks noGrp="1"/>
+          </p:cNvSpPr>
+          <p:nvPr>
+            <p:ph type="title"/>
+          </p:nvPr>
+        </p:nvSpPr>
+        <p:spPr>
+          <a:xfrm>
+            <a:off x="349956" y="273600"/>
+            <a:ext cx="4872936" cy="491331"/>
+          </a:xfrm>
+        </p:spPr>
+        <p:txBody>
+          <a:bodyPr/>
+          <a:lstStyle/>
+          <a:p>
+            <a:r>
+              <a:rPr lang="en-US" altLang="zh-TW" sz="2600" b="1" dirty="0">
+                <a:solidFill>
+                  <a:srgbClr val="183458"/>
+                </a:solidFill>
+                <a:latin typeface="Calibri"/>
+                <a:ea typeface="+mn-ea"/>
+                <a:cs typeface="+mn-cs"/>
+              </a:rPr>
+              <a:t>MDLA7 uArchSim Regression Table</a:t>
+            </a:r>
+            <a:r>
+              <a:rPr lang="zh-TW" altLang="en-US" sz="2600" b="1" dirty="0">
+                <a:solidFill>
+                  <a:srgbClr val="183458"/>
+                </a:solidFill>
+                <a:latin typeface="Calibri"/>
+                <a:ea typeface="+mn-ea"/>
+                <a:cs typeface="+mn-cs"/>
+              </a:rPr>
+              <a:t> </a:t>
+            </a:r>
+          </a:p>
+        </p:txBody>
+      </p:sp>
+      <p:sp>
+        <p:nvSpPr>
+          <p:cNvPr id="8" name="Rectangle 3">
+            <a:extLst>
+              <a:ext uri="{FF2B5EF4-FFF2-40B4-BE49-F238E27FC236}">
+                <a16:creationId xmlns:a16="http://schemas.microsoft.com/office/drawing/2014/main" id="{E7303A5A-E6DC-9BFF-BB18-40EE53CE7155}"/>
+              </a:ext>
+            </a:extLst>
+          </p:cNvPr>
+          <p:cNvSpPr/>
+          <p:nvPr/>
+        </p:nvSpPr>
+        <p:spPr>
+          <a:xfrm>
+            <a:off x="495480" y="764931"/>
+            <a:ext cx="11201040" cy="27000"/>
+          </a:xfrm>
+          <a:prstGeom prst="rect">
+            <a:avLst/>
+          </a:prstGeom>
+          <a:solidFill>
+            <a:srgbClr val="00897B"/>
+          </a:solidFill>
+          <a:ln>
+            <a:noFill/>
+          </a:ln>
+        </p:spPr>
+        <p:style>
+          <a:lnRef idx="1">
+            <a:schemeClr val="accent1"/>
+          </a:lnRef>
+          <a:fillRef idx="3">
+            <a:schemeClr val="accent1"/>
+          </a:fillRef>
+          <a:effectRef idx="2">
+            <a:schemeClr val="accent1"/>
+          </a:effectRef>
+          <a:fontRef idx="minor"/>
+        </p:style>
+        <p:txBody>
+          <a:bodyPr lIns="36720" tIns="13680" rIns="36720" bIns="13680" anchor="ctr">
+            <a:noAutofit/>
+          </a:bodyPr>
+          <a:lstStyle/>
+          <a:p>
+            <a:endParaRPr lang="en-US" sz="1800" b="0" u="none" strike="noStrike">
+              <a:solidFill>
+                <a:schemeClr val="lt1"/>
+              </a:solidFill>
+              <a:effectLst/>
+              <a:uFillTx/>
+              <a:latin typeface="Calibri"/>
+            </a:endParaRPr>
+          </a:p>
+        </p:txBody>
+      </p:sp>
+      <p:sp>
+        <p:nvSpPr>
+          <p:cNvPr id="9" name="TextBox 5">
+            <a:extLst>
+              <a:ext uri="{FF2B5EF4-FFF2-40B4-BE49-F238E27FC236}">
+                <a16:creationId xmlns:a16="http://schemas.microsoft.com/office/drawing/2014/main" id="{C642C401-A405-AB60-009F-A0BFD6BDC35A}"/>
+              </a:ext>
+            </a:extLst>
+          </p:cNvPr>
+          <p:cNvSpPr/>
+          <p:nvPr/>
+        </p:nvSpPr>
+        <p:spPr>
+          <a:xfrm>
+            <a:off x="973109" y="1119262"/>
+            <a:ext cx="4538133" cy="2330014"/>
+          </a:xfrm>
+          <a:prstGeom prst="rect">
+            <a:avLst/>
+          </a:prstGeom>
+          <a:noFill/>
+          <a:ln w="0">
+            <a:noFill/>
+          </a:ln>
+        </p:spPr>
+        <p:style>
+          <a:lnRef idx="0">
+            <a:scrgbClr r="0" g="0" b="0"/>
+          </a:lnRef>
+          <a:fillRef idx="0">
+            <a:scrgbClr r="0" g="0" b="0"/>
+          </a:fillRef>
+          <a:effectRef idx="0">
+            <a:scrgbClr r="0" g="0" b="0"/>
+          </a:effectRef>
+          <a:fontRef idx="minor"/>
+        </p:style>
+        <p:txBody>
+          <a:bodyPr wrap="square" lIns="36720" tIns="18360" rIns="36720" bIns="18360" anchor="t">
+            <a:spAutoFit/>
+          </a:bodyPr>
+          <a:lstStyle/>
+          <a:p>
+            <a:pPr marL="343080" indent="-343080" defTabSz="457200">
+              <a:lnSpc>
+                <a:spcPct val="100000"/>
+              </a:lnSpc>
+              <a:buClr>
+                <a:srgbClr val="183458"/>
+              </a:buClr>
+              <a:buFont typeface="Wingdings" charset="2"/>
+              <a:buChar char=""/>
+            </a:pPr>
+            <a:r>
+              <a:rPr lang="en-US" altLang="zh-TW" sz="1400" b="1" dirty="0">
+                <a:solidFill>
+                  <a:srgbClr val="183458"/>
+                </a:solidFill>
+                <a:latin typeface="Calibri"/>
+              </a:rPr>
+              <a:t>Clock</a:t>
+            </a:r>
+            <a:endParaRPr lang="en-US" altLang="zh-TW" sz="1400" b="1" u="none" strike="noStrike" dirty="0">
+              <a:solidFill>
+                <a:srgbClr val="183458"/>
+              </a:solidFill>
+              <a:effectLst/>
+              <a:uFillTx/>
+              <a:latin typeface="Calibri"/>
+            </a:endParaRPr>
+          </a:p>
+          <a:p>
+            <a:pPr marL="800280" lvl="1" indent="-343080" defTabSz="457200">
+              <a:buClr>
+                <a:srgbClr val="183458"/>
+              </a:buClr>
+              <a:buFont typeface="Arial" panose="020B0604020202020204" pitchFamily="34" charset="0"/>
+              <a:buChar char="•"/>
+            </a:pPr>
+            <a:r>
+              <a:rPr lang="en-US" sz="1400" b="1" dirty="0">
+                <a:solidFill>
+                  <a:srgbClr val="183458"/>
+                </a:solidFill>
+                <a:latin typeface="Calibri"/>
+              </a:rPr>
+              <a:t>Engine : 1.9GMHz</a:t>
+            </a:r>
+          </a:p>
+          <a:p>
+            <a:pPr marL="800280" lvl="1" indent="-343080" defTabSz="457200">
+              <a:buClr>
+                <a:srgbClr val="183458"/>
+              </a:buClr>
+              <a:buFont typeface="Arial" panose="020B0604020202020204" pitchFamily="34" charset="0"/>
+              <a:buChar char="•"/>
+            </a:pPr>
+            <a:r>
+              <a:rPr lang="en-US" sz="1400" b="1" u="none" strike="noStrike" dirty="0">
+                <a:solidFill>
+                  <a:srgbClr val="183458"/>
+                </a:solidFill>
+                <a:effectLst/>
+                <a:uFillTx/>
+                <a:latin typeface="Calibri"/>
+              </a:rPr>
+              <a:t>SRAM : 1.3G</a:t>
+            </a:r>
+          </a:p>
+          <a:p>
+            <a:pPr marL="343080" indent="-343080" defTabSz="457200">
+              <a:lnSpc>
+                <a:spcPct val="100000"/>
+              </a:lnSpc>
+              <a:buClr>
+                <a:srgbClr val="183458"/>
+              </a:buClr>
+              <a:buFont typeface="Wingdings" charset="2"/>
+              <a:buChar char=""/>
+            </a:pPr>
+            <a:r>
+              <a:rPr lang="en-US" sz="1400" b="1" u="none" strike="noStrike" dirty="0">
+                <a:solidFill>
+                  <a:srgbClr val="183458"/>
+                </a:solidFill>
+                <a:effectLst/>
+                <a:uFillTx/>
+                <a:latin typeface="Calibri"/>
+              </a:rPr>
+              <a:t>BW</a:t>
+            </a:r>
+          </a:p>
+          <a:p>
+            <a:pPr marL="800280" lvl="1" indent="-343080" defTabSz="457200">
+              <a:buClr>
+                <a:srgbClr val="183458"/>
+              </a:buClr>
+              <a:buFont typeface="Arial" panose="020B0604020202020204" pitchFamily="34" charset="0"/>
+              <a:buChar char="•"/>
+            </a:pPr>
+            <a:r>
+              <a:rPr lang="en-US" sz="1400" b="1" dirty="0">
+                <a:solidFill>
+                  <a:srgbClr val="183458"/>
+                </a:solidFill>
+                <a:latin typeface="Calibri"/>
+              </a:rPr>
+              <a:t>DRAM : LPDDR5</a:t>
+            </a:r>
+            <a:endParaRPr lang="en-US" sz="1400" b="1" u="none" strike="noStrike" dirty="0">
+              <a:solidFill>
+                <a:srgbClr val="183458"/>
+              </a:solidFill>
+              <a:effectLst/>
+              <a:uFillTx/>
+              <a:latin typeface="Calibri"/>
+            </a:endParaRPr>
+          </a:p>
+          <a:p>
+            <a:pPr marL="343080" indent="-343080" defTabSz="457200">
+              <a:lnSpc>
+                <a:spcPct val="100000"/>
+              </a:lnSpc>
+              <a:buClr>
+                <a:srgbClr val="183458"/>
+              </a:buClr>
+              <a:buFont typeface="Wingdings" charset="2"/>
+              <a:buChar char=""/>
+            </a:pPr>
+            <a:endParaRPr lang="en-US" sz="1400" b="1" dirty="0">
+              <a:solidFill>
+                <a:srgbClr val="183458"/>
+              </a:solidFill>
+              <a:latin typeface="Calibri"/>
+            </a:endParaRPr>
+          </a:p>
+          <a:p>
+            <a:pPr marL="343080" indent="-343080" defTabSz="457200">
+              <a:lnSpc>
+                <a:spcPct val="100000"/>
+              </a:lnSpc>
+              <a:buClr>
+                <a:srgbClr val="183458"/>
+              </a:buClr>
+              <a:buFont typeface="Wingdings" charset="2"/>
+              <a:buChar char=""/>
+            </a:pPr>
+            <a:r>
+              <a:rPr lang="en-US" sz="1400" b="1" dirty="0">
+                <a:solidFill>
+                  <a:srgbClr val="183458"/>
+                </a:solidFill>
+                <a:latin typeface="Calibri"/>
+              </a:rPr>
+              <a:t>Computer Power</a:t>
+            </a:r>
+          </a:p>
+          <a:p>
+            <a:pPr marL="800280" lvl="1" indent="-343080" defTabSz="457200">
+              <a:buClr>
+                <a:srgbClr val="183458"/>
+              </a:buClr>
+              <a:buFont typeface="Arial" panose="020B0604020202020204" pitchFamily="34" charset="0"/>
+              <a:buChar char="•"/>
+            </a:pPr>
+            <a:r>
+              <a:rPr lang="en-US" sz="1400" b="1" dirty="0">
+                <a:solidFill>
+                  <a:srgbClr val="183458"/>
+                </a:solidFill>
+                <a:latin typeface="Calibri"/>
+              </a:rPr>
+              <a:t>MDLA6: 4 Cores</a:t>
+            </a:r>
+          </a:p>
+          <a:p>
+            <a:pPr marL="800280" lvl="1" indent="-343080" defTabSz="457200">
+              <a:buClr>
+                <a:srgbClr val="183458"/>
+              </a:buClr>
+              <a:buFont typeface="Arial" panose="020B0604020202020204" pitchFamily="34" charset="0"/>
+              <a:buChar char="•"/>
+            </a:pPr>
+            <a:r>
+              <a:rPr lang="en-US" sz="1400" b="1" u="none" strike="noStrike" dirty="0">
+                <a:solidFill>
+                  <a:srgbClr val="183458"/>
+                </a:solidFill>
+                <a:effectLst/>
+                <a:uFillTx/>
+                <a:latin typeface="Calibri"/>
+              </a:rPr>
+              <a:t>MDLA7: 1 Cores ~~ MDLA6 2 Cores</a:t>
+            </a:r>
+          </a:p>
+          <a:p>
+            <a:pPr marL="343080" indent="-343080" defTabSz="457200">
+              <a:lnSpc>
+                <a:spcPct val="100000"/>
+              </a:lnSpc>
+              <a:buClr>
+                <a:srgbClr val="183458"/>
+              </a:buClr>
+              <a:buFont typeface="Wingdings" charset="2"/>
+              <a:buChar char=""/>
+            </a:pPr>
+            <a:endParaRPr lang="en-US" sz="1400" b="0" u="none" strike="noStrike" dirty="0">
+              <a:solidFill>
+                <a:srgbClr val="000000"/>
+              </a:solidFill>
+              <a:effectLst/>
+              <a:uFillTx/>
+              <a:latin typeface="Arial"/>
+            </a:endParaRPr>
+          </a:p>
+          <a:p>
+            <a:pPr lvl="1" defTabSz="457200">
+              <a:lnSpc>
+                <a:spcPct val="100000"/>
+              </a:lnSpc>
+              <a:buClr>
+                <a:srgbClr val="000000"/>
+              </a:buClr>
+            </a:pPr>
+            <a:endParaRPr lang="en-US" sz="1000" b="1" dirty="0">
+              <a:solidFill>
+                <a:schemeClr val="dk1"/>
+              </a:solidFill>
+              <a:latin typeface="Calibri"/>
+            </a:endParaRPr>
+          </a:p>
+        </p:txBody>
+      </p:sp>
+    </p:spTree>
+    <p:extLst>
+      <p:ext uri="{BB962C8B-B14F-4D97-AF65-F5344CB8AC3E}">
+        <p14:creationId xmlns:p14="http://schemas.microsoft.com/office/powerpoint/2010/main" val="1394525634"/>
+      </p:ext>
+    </p:extLst>
+  </p:cSld>
+  <p:clrMapOvr>
+    <a:masterClrMapping/>
+  </p:clrMapOvr>
+</p:sld>
+</file>
+
+<file path=ppt/slides/slide12.xml><?xml version="1.0" encoding="utf-8"?>
+<p:sld xmlns:a="http://schemas.openxmlformats.org/drawingml/2006/main" xmlns:r="http://schemas.openxmlformats.org/officeDocument/2006/relationships" xmlns:p="http://schemas.openxmlformats.org/presentationml/2006/main">
+  <p:cSld>
+    <p:spTree>
+      <p:nvGrpSpPr>
+        <p:cNvPr id="1" name=""/>
+        <p:cNvGrpSpPr/>
+        <p:nvPr/>
+      </p:nvGrpSpPr>
+      <p:grpSpPr>
+        <a:xfrm>
+          <a:off x="0" y="0"/>
+          <a:ext cx="0" cy="0"/>
+          <a:chOff x="0" y="0"/>
+          <a:chExt cx="0" cy="0"/>
+        </a:xfrm>
+      </p:grpSpPr>
+      <p:sp>
+        <p:nvSpPr>
+          <p:cNvPr id="2" name="標題 1">
+            <a:extLst>
+              <a:ext uri="{FF2B5EF4-FFF2-40B4-BE49-F238E27FC236}">
+                <a16:creationId xmlns:a16="http://schemas.microsoft.com/office/drawing/2014/main" id="{6221B0FC-C2F1-5E0E-8955-43C19321FD2F}"/>
+              </a:ext>
+            </a:extLst>
+          </p:cNvPr>
+          <p:cNvSpPr>
+            <a:spLocks noGrp="1"/>
+          </p:cNvSpPr>
+          <p:nvPr>
+            <p:ph type="title"/>
+          </p:nvPr>
+        </p:nvSpPr>
+        <p:spPr>
+          <a:xfrm>
+            <a:off x="609480" y="21033"/>
+            <a:ext cx="10972440" cy="742400"/>
+          </a:xfrm>
+        </p:spPr>
+        <p:txBody>
+          <a:bodyPr/>
+          <a:lstStyle/>
+          <a:p>
+            <a:r>
+              <a:rPr lang="en-US" altLang="zh-TW" sz="2600" b="1" dirty="0">
+                <a:solidFill>
+                  <a:srgbClr val="183458"/>
+                </a:solidFill>
+                <a:latin typeface="Calibri"/>
+                <a:ea typeface="+mn-ea"/>
+                <a:cs typeface="+mn-cs"/>
+              </a:rPr>
+              <a:t>L1Mesh Evaluation (v0.1 version)</a:t>
+            </a:r>
+            <a:endParaRPr lang="zh-TW" altLang="en-US" sz="2600" b="1" dirty="0">
+              <a:solidFill>
+                <a:srgbClr val="183458"/>
+              </a:solidFill>
+              <a:latin typeface="Calibri"/>
+              <a:ea typeface="+mn-ea"/>
+              <a:cs typeface="+mn-cs"/>
+            </a:endParaRPr>
+          </a:p>
+        </p:txBody>
+      </p:sp>
+      <p:sp>
+        <p:nvSpPr>
+          <p:cNvPr id="4" name="Rectangle 3">
+            <a:extLst>
+              <a:ext uri="{FF2B5EF4-FFF2-40B4-BE49-F238E27FC236}">
+                <a16:creationId xmlns:a16="http://schemas.microsoft.com/office/drawing/2014/main" id="{8A9B3F18-68BC-89E4-21B3-07D874E11828}"/>
+              </a:ext>
+            </a:extLst>
+          </p:cNvPr>
+          <p:cNvSpPr/>
+          <p:nvPr/>
+        </p:nvSpPr>
+        <p:spPr>
+          <a:xfrm>
+            <a:off x="380880" y="640657"/>
+            <a:ext cx="11201040" cy="27000"/>
+          </a:xfrm>
+          <a:prstGeom prst="rect">
+            <a:avLst/>
+          </a:prstGeom>
+          <a:solidFill>
+            <a:srgbClr val="00897B"/>
+          </a:solidFill>
+          <a:ln>
+            <a:noFill/>
+          </a:ln>
+        </p:spPr>
+        <p:style>
+          <a:lnRef idx="1">
+            <a:schemeClr val="accent1"/>
+          </a:lnRef>
+          <a:fillRef idx="3">
+            <a:schemeClr val="accent1"/>
+          </a:fillRef>
+          <a:effectRef idx="2">
+            <a:schemeClr val="accent1"/>
+          </a:effectRef>
+          <a:fontRef idx="minor"/>
+        </p:style>
+        <p:txBody>
+          <a:bodyPr lIns="36720" tIns="13680" rIns="36720" bIns="13680" anchor="ctr">
+            <a:noAutofit/>
+          </a:bodyPr>
+          <a:lstStyle/>
+          <a:p>
+            <a:endParaRPr lang="en-US" sz="1800" b="0" u="none" strike="noStrike">
+              <a:solidFill>
+                <a:schemeClr val="lt1"/>
+              </a:solidFill>
+              <a:effectLst/>
+              <a:uFillTx/>
+              <a:latin typeface="Calibri"/>
+            </a:endParaRPr>
+          </a:p>
+        </p:txBody>
+      </p:sp>
+      <p:sp>
+        <p:nvSpPr>
+          <p:cNvPr id="5" name="TextBox 5">
+            <a:extLst>
+              <a:ext uri="{FF2B5EF4-FFF2-40B4-BE49-F238E27FC236}">
+                <a16:creationId xmlns:a16="http://schemas.microsoft.com/office/drawing/2014/main" id="{69665232-E357-2A11-F3CB-FAA9D3E552D9}"/>
+              </a:ext>
+            </a:extLst>
+          </p:cNvPr>
+          <p:cNvSpPr/>
+          <p:nvPr/>
+        </p:nvSpPr>
+        <p:spPr>
+          <a:xfrm>
+            <a:off x="305323" y="904923"/>
+            <a:ext cx="8786426" cy="621854"/>
+          </a:xfrm>
+          <a:prstGeom prst="rect">
+            <a:avLst/>
+          </a:prstGeom>
+          <a:noFill/>
+          <a:ln w="0">
+            <a:noFill/>
+          </a:ln>
+        </p:spPr>
+        <p:style>
+          <a:lnRef idx="0">
+            <a:scrgbClr r="0" g="0" b="0"/>
+          </a:lnRef>
+          <a:fillRef idx="0">
+            <a:scrgbClr r="0" g="0" b="0"/>
+          </a:fillRef>
+          <a:effectRef idx="0">
+            <a:scrgbClr r="0" g="0" b="0"/>
+          </a:effectRef>
+          <a:fontRef idx="minor"/>
+        </p:style>
+        <p:txBody>
+          <a:bodyPr wrap="square" lIns="36720" tIns="18360" rIns="36720" bIns="18360" anchor="t">
+            <a:spAutoFit/>
+          </a:bodyPr>
+          <a:lstStyle/>
+          <a:p>
+            <a:pPr marL="343080" indent="-343080" defTabSz="457200">
+              <a:lnSpc>
+                <a:spcPct val="100000"/>
+              </a:lnSpc>
+              <a:buClr>
+                <a:srgbClr val="183458"/>
+              </a:buClr>
+              <a:buFont typeface="Wingdings" charset="2"/>
+              <a:buChar char=""/>
+            </a:pPr>
+            <a:r>
+              <a:rPr lang="en-US" altLang="zh-TW" sz="2400" b="1" dirty="0">
+                <a:solidFill>
+                  <a:srgbClr val="183458"/>
+                </a:solidFill>
+                <a:latin typeface="Calibri"/>
+              </a:rPr>
+              <a:t>L1Mesh Simulation Mode : </a:t>
+            </a:r>
+            <a:r>
+              <a:rPr lang="en-US" sz="2400" b="1" u="none" strike="noStrike" dirty="0">
+                <a:solidFill>
+                  <a:srgbClr val="183458"/>
+                </a:solidFill>
+                <a:effectLst/>
+                <a:uFillTx/>
+                <a:latin typeface="Calibri"/>
+              </a:rPr>
+              <a:t>Fast/S</a:t>
+            </a:r>
+            <a:r>
+              <a:rPr lang="en-US" sz="2400" b="1" dirty="0">
+                <a:solidFill>
+                  <a:srgbClr val="183458"/>
+                </a:solidFill>
+                <a:latin typeface="Calibri"/>
+              </a:rPr>
+              <a:t>RAM Port Conflict/Mesh</a:t>
+            </a:r>
+            <a:endParaRPr lang="en-US" sz="2400" b="0" u="none" strike="noStrike" dirty="0">
+              <a:solidFill>
+                <a:srgbClr val="000000"/>
+              </a:solidFill>
+              <a:effectLst/>
+              <a:uFillTx/>
+              <a:latin typeface="Arial"/>
+            </a:endParaRPr>
+          </a:p>
+          <a:p>
+            <a:pPr lvl="1" defTabSz="457200">
+              <a:lnSpc>
+                <a:spcPct val="100000"/>
+              </a:lnSpc>
+              <a:buClr>
+                <a:srgbClr val="000000"/>
+              </a:buClr>
+            </a:pPr>
+            <a:endParaRPr lang="en-US" sz="1400" b="1" dirty="0">
+              <a:solidFill>
+                <a:schemeClr val="dk1"/>
+              </a:solidFill>
+              <a:latin typeface="Calibri"/>
+            </a:endParaRPr>
+          </a:p>
+        </p:txBody>
+      </p:sp>
+      <p:pic>
+        <p:nvPicPr>
+          <p:cNvPr id="6" name="圖片 5">
+            <a:extLst>
+              <a:ext uri="{FF2B5EF4-FFF2-40B4-BE49-F238E27FC236}">
+                <a16:creationId xmlns:a16="http://schemas.microsoft.com/office/drawing/2014/main" id="{0B08516A-4508-0966-60DC-76173768D503}"/>
+              </a:ext>
+            </a:extLst>
+          </p:cNvPr>
+          <p:cNvPicPr>
+            <a:picLocks noChangeAspect="1"/>
+          </p:cNvPicPr>
+          <p:nvPr/>
+        </p:nvPicPr>
+        <p:blipFill>
+          <a:blip r:embed="rId2">
+            <a:extLst>
+              <a:ext uri="{28A0092B-C50C-407E-A947-70E740481C1C}">
+                <a14:useLocalDpi xmlns:a14="http://schemas.microsoft.com/office/drawing/2010/main" val="0"/>
+              </a:ext>
+            </a:extLst>
+          </a:blip>
+          <a:srcRect t="7242" b="14703"/>
+          <a:stretch>
+            <a:fillRect/>
+          </a:stretch>
+        </p:blipFill>
+        <p:spPr>
+          <a:xfrm>
+            <a:off x="141155" y="1894690"/>
+            <a:ext cx="11771553" cy="4487818"/>
+          </a:xfrm>
+          <a:prstGeom prst="rect">
+            <a:avLst/>
+          </a:prstGeom>
+        </p:spPr>
+      </p:pic>
+    </p:spTree>
+    <p:extLst>
+      <p:ext uri="{BB962C8B-B14F-4D97-AF65-F5344CB8AC3E}">
+        <p14:creationId xmlns:p14="http://schemas.microsoft.com/office/powerpoint/2010/main" val="602367366"/>
+      </p:ext>
+    </p:extLst>
+  </p:cSld>
+  <p:clrMapOvr>
+    <a:masterClrMapping/>
+  </p:clrMapOvr>
+</p:sld>
+</file>
+
+<file path=ppt/slides/slide13.xml><?xml version="1.0" encoding="utf-8"?>
+<p:sld xmlns:a="http://schemas.openxmlformats.org/drawingml/2006/main" xmlns:r="http://schemas.openxmlformats.org/officeDocument/2006/relationships" xmlns:p="http://schemas.openxmlformats.org/presentationml/2006/main">
+  <p:cSld>
+    <p:spTree>
+      <p:nvGrpSpPr>
+        <p:cNvPr id="1" name=""/>
+        <p:cNvGrpSpPr/>
+        <p:nvPr/>
+      </p:nvGrpSpPr>
+      <p:grpSpPr>
+        <a:xfrm>
+          <a:off x="0" y="0"/>
+          <a:ext cx="0" cy="0"/>
+          <a:chOff x="0" y="0"/>
+          <a:chExt cx="0" cy="0"/>
+        </a:xfrm>
+      </p:grpSpPr>
       <p:sp>
         <p:nvSpPr>
           <p:cNvPr id="197" name="TextBox 1"/>
@@ -8061,8 +8789,8 @@
         </p:nvSpPr>
         <p:spPr>
           <a:xfrm>
-            <a:off x="1610280" y="1229040"/>
-            <a:ext cx="8986320" cy="5453946"/>
+            <a:off x="957137" y="1375830"/>
+            <a:ext cx="8986320" cy="4746060"/>
           </a:xfrm>
           <a:prstGeom prst="rect">
             <a:avLst/>
@@ -8101,7 +8829,7 @@
               <a:buChar char=""/>
             </a:pPr>
             <a:r>
-              <a:rPr lang="en-US" sz="3200" b="1" u="none" strike="noStrike" dirty="0">
+              <a:rPr lang="en-US" sz="2800" b="1" u="none" strike="noStrike" dirty="0">
                 <a:solidFill>
                   <a:srgbClr val="183458"/>
                 </a:solidFill>
@@ -8112,7 +8840,7 @@
               <a:t>Tunning</a:t>
             </a:r>
             <a:r>
-              <a:rPr lang="zh-TW" altLang="en-US" sz="3200" b="1" u="none" strike="noStrike" dirty="0">
+              <a:rPr lang="zh-TW" altLang="en-US" sz="2800" b="1" u="none" strike="noStrike" dirty="0">
                 <a:solidFill>
                   <a:srgbClr val="183458"/>
                 </a:solidFill>
@@ -8123,7 +8851,7 @@
               <a:t> </a:t>
             </a:r>
             <a:r>
-              <a:rPr lang="en-US" altLang="zh-TW" sz="3200" b="1" dirty="0">
+              <a:rPr lang="en-US" altLang="zh-TW" sz="2800" b="1" dirty="0">
                 <a:solidFill>
                   <a:srgbClr val="183458"/>
                 </a:solidFill>
@@ -8141,7 +8869,7 @@
               <a:buChar char="l"/>
             </a:pPr>
             <a:r>
-              <a:rPr lang="en-US" sz="2800" b="1" u="none" strike="noStrike" dirty="0">
+              <a:rPr lang="en-US" sz="2400" b="1" u="none" strike="noStrike" dirty="0">
                 <a:solidFill>
                   <a:srgbClr val="183458"/>
                 </a:solidFill>
@@ -8151,7 +8879,7 @@
               </a:rPr>
               <a:t>Baseline profiling</a:t>
             </a:r>
-            <a:endParaRPr lang="en-US" sz="2800" dirty="0">
+            <a:endParaRPr lang="en-US" sz="2400" dirty="0">
               <a:solidFill>
                 <a:srgbClr val="000000"/>
               </a:solidFill>
@@ -8167,7 +8895,7 @@
               <a:buChar char="l"/>
             </a:pPr>
             <a:r>
-              <a:rPr lang="en-US" sz="2800" b="1" u="none" strike="noStrike" dirty="0">
+              <a:rPr lang="en-US" sz="2400" b="1" u="none" strike="noStrike" dirty="0">
                 <a:solidFill>
                   <a:srgbClr val="183458"/>
                 </a:solidFill>
@@ -8177,7 +8905,7 @@
               </a:rPr>
               <a:t>Tiling and micro-blocks</a:t>
             </a:r>
-            <a:endParaRPr lang="en-US" sz="2800" dirty="0">
+            <a:endParaRPr lang="en-US" sz="2400" dirty="0">
               <a:solidFill>
                 <a:srgbClr val="000000"/>
               </a:solidFill>
@@ -8193,7 +8921,7 @@
               <a:buChar char="l"/>
             </a:pPr>
             <a:r>
-              <a:rPr lang="en-US" sz="2800" b="1" u="none" strike="noStrike" dirty="0">
+              <a:rPr lang="en-US" sz="2400" b="1" u="none" strike="noStrike" dirty="0">
                 <a:solidFill>
                   <a:srgbClr val="183458"/>
                 </a:solidFill>
@@ -8203,7 +8931,7 @@
               </a:rPr>
               <a:t>Layer Fuse</a:t>
             </a:r>
-            <a:endParaRPr lang="en-US" sz="2800" dirty="0">
+            <a:endParaRPr lang="en-US" sz="2400" dirty="0">
               <a:solidFill>
                 <a:srgbClr val="000000"/>
               </a:solidFill>
@@ -8219,7 +8947,7 @@
               <a:buChar char="l"/>
             </a:pPr>
             <a:r>
-              <a:rPr lang="en-US" sz="2800" b="1" u="none" strike="noStrike" dirty="0">
+              <a:rPr lang="en-US" sz="2400" b="1" u="none" strike="noStrike" dirty="0">
                 <a:solidFill>
                   <a:srgbClr val="183458"/>
                 </a:solidFill>
@@ -8239,7 +8967,7 @@
               <a:buChar char="l"/>
             </a:pPr>
             <a:r>
-              <a:rPr lang="en-US" sz="2800" b="1" u="none" strike="noStrike" dirty="0">
+              <a:rPr lang="en-US" sz="2400" b="1" u="none" strike="noStrike" dirty="0">
                 <a:solidFill>
                   <a:srgbClr val="183458"/>
                 </a:solidFill>
@@ -8249,7 +8977,7 @@
               </a:rPr>
               <a:t>Engine Bubbles</a:t>
             </a:r>
-            <a:endParaRPr lang="en-US" sz="2800" b="0" u="none" strike="noStrike" dirty="0">
+            <a:endParaRPr lang="en-US" sz="2400" b="0" u="none" strike="noStrike" dirty="0">
               <a:solidFill>
                 <a:srgbClr val="000000"/>
               </a:solidFill>
@@ -8269,7 +8997,7 @@
               <a:buFont typeface="Wingdings" charset="2"/>
               <a:buChar char=""/>
             </a:pPr>
-            <a:endParaRPr lang="en-US" sz="3200" b="1" u="none" strike="noStrike" dirty="0">
+            <a:endParaRPr lang="en-US" sz="2800" b="1" u="none" strike="noStrike" dirty="0">
               <a:solidFill>
                 <a:srgbClr val="183458"/>
               </a:solidFill>
@@ -8290,7 +9018,7 @@
               <a:buChar char=""/>
             </a:pPr>
             <a:r>
-              <a:rPr lang="en-US" sz="3200" b="1" u="none" strike="noStrike" dirty="0">
+              <a:rPr lang="en-US" sz="2800" b="1" u="none" strike="noStrike" dirty="0">
                 <a:solidFill>
                   <a:srgbClr val="183458"/>
                 </a:solidFill>
@@ -8300,7 +9028,7 @@
               </a:rPr>
               <a:t>Prompt Examples</a:t>
             </a:r>
-            <a:endParaRPr lang="en-US" sz="3200" b="0" u="none" strike="noStrike" dirty="0">
+            <a:endParaRPr lang="en-US" sz="2800" b="0" u="none" strike="noStrike" dirty="0">
               <a:solidFill>
                 <a:srgbClr val="000000"/>
               </a:solidFill>
@@ -8321,7 +9049,7 @@
               <a:buChar char=""/>
             </a:pPr>
             <a:r>
-              <a:rPr lang="en-US" sz="1800" b="1" u="none" strike="noStrike" dirty="0">
+              <a:rPr lang="en-US" sz="1600" b="1" u="none" strike="noStrike" dirty="0">
                 <a:solidFill>
                   <a:schemeClr val="dk1"/>
                 </a:solidFill>
@@ -8332,7 +9060,7 @@
               <a:t>/goal E2E function 100%, turning performance </a:t>
             </a:r>
             <a:r>
-              <a:rPr lang="en-US" sz="1800" b="1" u="none" strike="noStrike" dirty="0" err="1">
+              <a:rPr lang="en-US" sz="1600" b="1" u="none" strike="noStrike" dirty="0" err="1">
                 <a:solidFill>
                   <a:schemeClr val="dk1"/>
                 </a:solidFill>
@@ -8343,7 +9071,7 @@
               <a:t>不能掉</a:t>
             </a:r>
             <a:r>
-              <a:rPr lang="en-US" sz="1800" b="1" u="none" strike="noStrike" dirty="0">
+              <a:rPr lang="en-US" sz="1600" b="1" u="none" strike="noStrike" dirty="0">
                 <a:solidFill>
                   <a:schemeClr val="dk1"/>
                 </a:solidFill>
@@ -8354,7 +9082,7 @@
               <a:t>, </a:t>
             </a:r>
             <a:r>
-              <a:rPr lang="en-US" b="1" dirty="0">
+              <a:rPr lang="en-US" sz="1600" b="1" dirty="0">
                 <a:solidFill>
                   <a:schemeClr val="dk1"/>
                 </a:solidFill>
@@ -8363,7 +9091,7 @@
               <a:t> </a:t>
             </a:r>
             <a:r>
-              <a:rPr lang="en-US" b="1" dirty="0" err="1">
+              <a:rPr lang="en-US" sz="1600" b="1" dirty="0" err="1">
                 <a:solidFill>
                   <a:schemeClr val="dk1"/>
                 </a:solidFill>
@@ -8372,7 +9100,7 @@
               <a:t>算法</a:t>
             </a:r>
             <a:r>
-              <a:rPr lang="zh-TW" altLang="en-US" b="1" dirty="0">
+              <a:rPr lang="zh-TW" altLang="en-US" sz="1600" b="1" dirty="0">
                 <a:solidFill>
                   <a:schemeClr val="dk1"/>
                 </a:solidFill>
@@ -8381,7 +9109,7 @@
               <a:t> </a:t>
             </a:r>
             <a:r>
-              <a:rPr lang="en-US" sz="1800" b="1" u="none" strike="noStrike" dirty="0" err="1">
+              <a:rPr lang="en-US" sz="1600" b="1" u="none" strike="noStrike" dirty="0" err="1">
                 <a:solidFill>
                   <a:schemeClr val="dk1"/>
                 </a:solidFill>
@@ -8392,7 +9120,7 @@
               <a:t>要是</a:t>
             </a:r>
             <a:r>
-              <a:rPr lang="zh-TW" altLang="en-US" sz="1800" b="1" u="none" strike="noStrike" dirty="0">
+              <a:rPr lang="zh-TW" altLang="en-US" sz="1600" b="1" u="none" strike="noStrike" dirty="0">
                 <a:solidFill>
                   <a:schemeClr val="dk1"/>
                 </a:solidFill>
@@ -8403,7 +9131,7 @@
               <a:t> </a:t>
             </a:r>
             <a:r>
-              <a:rPr lang="en-US" altLang="zh-TW" sz="1800" b="1" u="none" strike="noStrike" dirty="0">
+              <a:rPr lang="en-US" altLang="zh-TW" sz="1600" b="1" u="none" strike="noStrike" dirty="0">
                 <a:solidFill>
                   <a:schemeClr val="dk1"/>
                 </a:solidFill>
@@ -8413,7 +9141,7 @@
               </a:rPr>
               <a:t>general rule</a:t>
             </a:r>
-            <a:endParaRPr lang="en-US" sz="1800" b="1" u="none" strike="noStrike" dirty="0">
+            <a:endParaRPr lang="en-US" sz="1600" b="1" u="none" strike="noStrike" dirty="0">
               <a:solidFill>
                 <a:schemeClr val="dk1"/>
               </a:solidFill>
@@ -8434,7 +9162,7 @@
               <a:buChar char=""/>
             </a:pPr>
             <a:r>
-              <a:rPr lang="en-US" sz="1800" b="1" u="none" strike="noStrike" dirty="0">
+              <a:rPr lang="en-US" sz="1600" b="1" u="none" strike="noStrike" dirty="0">
                 <a:solidFill>
                   <a:schemeClr val="dk1"/>
                 </a:solidFill>
@@ -8442,10 +9170,32 @@
                 <a:uFillTx/>
                 <a:latin typeface="Calibri"/>
               </a:rPr>
+              <a:t>Check</a:t>
+            </a:r>
+            <a:r>
+              <a:rPr lang="zh-TW" altLang="en-US" sz="1600" b="1" u="none" strike="noStrike" dirty="0">
+                <a:solidFill>
+                  <a:schemeClr val="dk1"/>
+                </a:solidFill>
+                <a:effectLst/>
+                <a:uFillTx/>
+                <a:latin typeface="Calibri"/>
+              </a:rPr>
+              <a:t> </a:t>
+            </a:r>
+            <a:r>
+              <a:rPr lang="en-US" sz="1600" b="1" u="none" strike="noStrike" dirty="0">
+                <a:solidFill>
+                  <a:schemeClr val="dk1"/>
+                </a:solidFill>
+                <a:effectLst/>
+                <a:uFillTx/>
+                <a:latin typeface="Calibri"/>
+              </a:rPr>
               <a:t>ETHZ_V6 </a:t>
             </a:r>
             <a:r>
-              <a:rPr lang="zh-TW" sz="1800" b="1" u="none" strike="noStrike" dirty="0">
+              <a:rPr lang="zh-TW" sz="1600" b="1" u="none" strike="noStrike" dirty="0">
                 <a:solidFill>
                   <a:schemeClr val="dk1"/>
                 </a:solidFill>
@@ -8456,7 +9206,7 @@
               <a:t>不是最後一層有</a:t>
             </a:r>
             <a:r>
-              <a:rPr lang="en-US" sz="1800" b="1" u="none" strike="noStrike" dirty="0">
+              <a:rPr lang="zh-TW" altLang="en-US" sz="1600" b="1" u="none" strike="noStrike" dirty="0">
                 <a:solidFill>
                   <a:schemeClr val="dk1"/>
                 </a:solidFill>
@@ -8464,10 +9214,10 @@
                 <a:uFillTx/>
                 <a:latin typeface="Calibri"/>
               </a:rPr>
-              <a:t>DRAM_W  </a:t>
-            </a:r>
-            <a:r>
-              <a:rPr lang="zh-TW" sz="1800" b="1" u="none" strike="noStrike" dirty="0">
+              <a:t>大量的 </a:t>
+            </a:r>
+            <a:r>
+              <a:rPr lang="en-US" sz="1600" b="1" u="none" strike="noStrike" dirty="0">
                 <a:solidFill>
                   <a:schemeClr val="dk1"/>
                 </a:solidFill>
@@ -8475,9 +9225,64 @@
                 <a:uFillTx/>
                 <a:latin typeface="Calibri"/>
               </a:rPr>
-              <a:t>都拿來最佳化</a:t>
-            </a:r>
-            <a:endParaRPr lang="en-US" sz="1800" b="0" u="none" strike="noStrike" dirty="0">
+              <a:t>DRAM</a:t>
+            </a:r>
+            <a:r>
+              <a:rPr lang="zh-TW" altLang="en-US" sz="1600" b="1" u="none" strike="noStrike" dirty="0">
+                <a:solidFill>
+                  <a:schemeClr val="dk1"/>
+                </a:solidFill>
+                <a:effectLst/>
+                <a:uFillTx/>
+                <a:latin typeface="Calibri"/>
+              </a:rPr>
+              <a:t> </a:t>
+            </a:r>
+            <a:r>
+              <a:rPr lang="en-US" sz="1600" b="1" u="none" strike="noStrike" dirty="0">
+                <a:solidFill>
+                  <a:schemeClr val="dk1"/>
+                </a:solidFill>
+                <a:effectLst/>
+                <a:uFillTx/>
+                <a:latin typeface="Calibri"/>
+              </a:rPr>
+              <a:t>Write  </a:t>
+            </a:r>
+            <a:r>
+              <a:rPr lang="en-US" sz="1600" b="1" u="none" strike="noStrike" dirty="0" err="1">
+                <a:solidFill>
+                  <a:schemeClr val="dk1"/>
+                </a:solidFill>
+                <a:effectLst/>
+                <a:uFillTx/>
+                <a:latin typeface="Calibri"/>
+              </a:rPr>
+              <a:t>列出來</a:t>
+            </a:r>
+            <a:r>
+              <a:rPr lang="zh-TW" altLang="en-US" sz="1600" b="1" u="none" strike="noStrike" dirty="0">
+                <a:solidFill>
+                  <a:schemeClr val="dk1"/>
+                </a:solidFill>
+                <a:effectLst/>
+                <a:uFillTx/>
+                <a:latin typeface="Calibri"/>
+              </a:rPr>
+              <a:t> 然後</a:t>
+            </a:r>
+            <a:r>
+              <a:rPr lang="zh-TW" sz="1600" b="1" u="none" strike="noStrike" dirty="0">
+                <a:solidFill>
+                  <a:schemeClr val="dk1"/>
+                </a:solidFill>
+                <a:effectLst/>
+                <a:uFillTx/>
+                <a:latin typeface="Calibri"/>
+              </a:rPr>
+              <a:t>最佳化</a:t>
+            </a:r>
+            <a:endParaRPr lang="en-US" sz="1600" b="0" u="none" strike="noStrike" dirty="0">
               <a:solidFill>
                 <a:srgbClr val="000000"/>
               </a:solidFill>
@@ -8498,63 +9303,134 @@
               <a:buChar char=""/>
             </a:pPr>
             <a:r>
-              <a:rPr lang="en" sz="1800" b="1" u="none" strike="noStrike" dirty="0">
+              <a:rPr lang="en-US" altLang="zh-TW" sz="1600" b="1" dirty="0">
                 <a:solidFill>
                   <a:schemeClr val="dk1"/>
                 </a:solidFill>
-                <a:effectLst/>
-                <a:uFillTx/>
-                <a:latin typeface="Calibri"/>
-              </a:rPr>
-              <a:t>unet_int16.tflite L7-L10 </a:t>
-            </a:r>
-            <a:r>
-              <a:rPr lang="zh-TW" sz="1800" b="1" u="none" strike="noStrike" dirty="0">
+              </a:rPr>
+              <a:t>Check</a:t>
+            </a:r>
+            <a:r>
+              <a:rPr lang="zh-TW" altLang="en-US" sz="1600" b="1" dirty="0">
                 <a:solidFill>
                   <a:schemeClr val="dk1"/>
                 </a:solidFill>
-                <a:effectLst/>
-                <a:uFillTx/>
-                <a:latin typeface="Calibri"/>
-              </a:rPr>
-              <a:t>可以 </a:t>
-            </a:r>
-            <a:r>
-              <a:rPr lang="en-US" sz="1800" b="1" u="none" strike="noStrike" dirty="0">
+              </a:rPr>
+              <a:t> </a:t>
+            </a:r>
+            <a:r>
+              <a:rPr lang="en-US" altLang="zh-TW" sz="1600" b="1" dirty="0">
                 <a:solidFill>
                   <a:schemeClr val="dk1"/>
                 </a:solidFill>
-                <a:effectLst/>
-                <a:uFillTx/>
-                <a:latin typeface="Calibri"/>
-              </a:rPr>
-              <a:t>Fuse </a:t>
-            </a:r>
-            <a:r>
-              <a:rPr lang="zh-TW" sz="1800" b="1" u="none" strike="noStrike" dirty="0">
+              </a:rPr>
+              <a:t>ETHZ_V6 </a:t>
+            </a:r>
+            <a:r>
+              <a:rPr lang="zh-TW" altLang="en-US" sz="1600" b="1" dirty="0">
                 <a:solidFill>
                   <a:schemeClr val="dk1"/>
                 </a:solidFill>
-                <a:effectLst/>
-                <a:uFillTx/>
-                <a:latin typeface="Calibri"/>
-              </a:rPr>
-              <a:t>起來嗎</a:t>
-            </a:r>
-            <a:endParaRPr lang="en-US" sz="1800" b="0" u="none" strike="noStrike" dirty="0">
+              </a:rPr>
+              <a:t> </a:t>
+            </a:r>
+            <a:r>
+              <a:rPr lang="en-US" altLang="zh-TW" sz="1600" b="1" dirty="0">
+                <a:solidFill>
+                  <a:schemeClr val="dk1"/>
+                </a:solidFill>
+              </a:rPr>
+              <a:t>Layer</a:t>
+            </a:r>
+            <a:r>
+              <a:rPr lang="zh-TW" altLang="en-US" sz="1600" b="1" dirty="0">
+                <a:solidFill>
+                  <a:schemeClr val="dk1"/>
+                </a:solidFill>
+              </a:rPr>
+              <a:t> 可以</a:t>
+            </a:r>
+            <a:r>
+              <a:rPr lang="en-US" altLang="zh-TW" sz="1600" b="1" dirty="0">
+                <a:solidFill>
+                  <a:schemeClr val="dk1"/>
+                </a:solidFill>
+              </a:rPr>
+              <a:t>Fuse</a:t>
+            </a:r>
+            <a:r>
+              <a:rPr lang="zh-TW" altLang="en-US" sz="1600" b="1" dirty="0">
+                <a:solidFill>
+                  <a:schemeClr val="dk1"/>
+                </a:solidFill>
+              </a:rPr>
+              <a:t> 成 </a:t>
+            </a:r>
+            <a:r>
+              <a:rPr lang="en-US" altLang="zh-TW" sz="1600" b="1" dirty="0">
+                <a:solidFill>
+                  <a:schemeClr val="dk1"/>
+                </a:solidFill>
+              </a:rPr>
+              <a:t>Flow</a:t>
+            </a:r>
+            <a:r>
+              <a:rPr lang="zh-TW" altLang="en-US" sz="1600" b="1" dirty="0">
+                <a:solidFill>
+                  <a:schemeClr val="dk1"/>
+                </a:solidFill>
+              </a:rPr>
+              <a:t> 沒 </a:t>
+            </a:r>
+            <a:r>
+              <a:rPr lang="en-US" altLang="zh-TW" sz="1600" b="1" dirty="0">
+                <a:solidFill>
+                  <a:schemeClr val="dk1"/>
+                </a:solidFill>
+              </a:rPr>
+              <a:t>Fuse</a:t>
+            </a:r>
+            <a:r>
+              <a:rPr lang="zh-TW" altLang="en-US" sz="1600" b="1" dirty="0">
+                <a:solidFill>
+                  <a:schemeClr val="dk1"/>
+                </a:solidFill>
+              </a:rPr>
+              <a:t>起來的  </a:t>
+            </a:r>
+            <a:r>
+              <a:rPr lang="en-US" altLang="zh-TW" sz="1600" b="1" dirty="0" err="1">
+                <a:solidFill>
+                  <a:schemeClr val="dk1"/>
+                </a:solidFill>
+              </a:rPr>
+              <a:t>列出來</a:t>
+            </a:r>
+            <a:r>
+              <a:rPr lang="zh-TW" altLang="en-US" sz="1600" b="1" dirty="0">
+                <a:solidFill>
+                  <a:schemeClr val="dk1"/>
+                </a:solidFill>
+              </a:rPr>
+              <a:t> 然後</a:t>
+            </a:r>
+            <a:r>
+              <a:rPr lang="zh-TW" altLang="zh-TW" sz="1600" b="1" dirty="0">
+                <a:solidFill>
+                  <a:schemeClr val="dk1"/>
+                </a:solidFill>
+              </a:rPr>
+              <a:t>最佳化</a:t>
+            </a:r>
+            <a:endParaRPr lang="en-US" altLang="zh-TW" sz="1600" dirty="0">
               <a:solidFill>
                 <a:srgbClr val="000000"/>
               </a:solidFill>
-              <a:effectLst/>
-              <a:uFillTx/>
               <a:latin typeface="Arial"/>
             </a:endParaRPr>
           </a:p>
           <a:p>
             <a:pPr marL="800280" lvl="1" indent="-343080" defTabSz="457200">
-              <a:lnSpc>
-                <a:spcPct val="100000"/>
-              </a:lnSpc>
               <a:buClr>
                 <a:srgbClr val="000000"/>
               </a:buClr>
@@ -8562,74 +9438,85 @@
               <a:buChar char=""/>
             </a:pPr>
             <a:r>
-              <a:rPr lang="en" sz="1800" b="1" u="none" strike="noStrike" dirty="0">
+              <a:rPr lang="en-US" altLang="zh-TW" sz="1600" b="1" dirty="0">
                 <a:solidFill>
                   <a:schemeClr val="dk1"/>
                 </a:solidFill>
-                <a:effectLst/>
-                <a:uFillTx/>
-                <a:latin typeface="Calibri"/>
-              </a:rPr>
-              <a:t>yolo_v8_float.tflite </a:t>
-            </a:r>
-            <a:r>
-              <a:rPr lang="en-US" sz="1800" b="1" u="none" strike="noStrike" dirty="0">
+              </a:rPr>
+              <a:t>Check</a:t>
+            </a:r>
+            <a:r>
+              <a:rPr lang="zh-TW" altLang="en-US" sz="1600" b="1" dirty="0">
                 <a:solidFill>
                   <a:schemeClr val="dk1"/>
                 </a:solidFill>
-                <a:effectLst/>
-                <a:uFillTx/>
-                <a:latin typeface="Calibri"/>
-              </a:rPr>
-              <a:t>L80-L86 </a:t>
-            </a:r>
-            <a:r>
-              <a:rPr lang="zh-TW" sz="1800" b="1" u="none" strike="noStrike" dirty="0">
+              </a:rPr>
+              <a:t> </a:t>
+            </a:r>
+            <a:r>
+              <a:rPr lang="en-US" altLang="zh-TW" sz="1600" b="1" dirty="0">
                 <a:solidFill>
                   <a:schemeClr val="dk1"/>
                 </a:solidFill>
-                <a:effectLst/>
-                <a:uFillTx/>
-                <a:latin typeface="Calibri"/>
-              </a:rPr>
-              <a:t>可以 </a:t>
-            </a:r>
-            <a:r>
-              <a:rPr lang="en-US" sz="1800" b="1" u="none" strike="noStrike" dirty="0">
+              </a:rPr>
+              <a:t>ETHZ_V6 Flow</a:t>
+            </a:r>
+            <a:r>
+              <a:rPr lang="zh-TW" altLang="en-US" sz="1600" b="1" dirty="0">
                 <a:solidFill>
                   <a:schemeClr val="dk1"/>
                 </a:solidFill>
-                <a:effectLst/>
-                <a:uFillTx/>
-                <a:latin typeface="Calibri"/>
-              </a:rPr>
-              <a:t>Overlap </a:t>
-            </a:r>
-            <a:r>
-              <a:rPr lang="zh-TW" sz="1800" b="1" u="none" strike="noStrike" dirty="0">
+              </a:rPr>
+              <a:t> 沒有切成 </a:t>
+            </a:r>
+            <a:r>
+              <a:rPr lang="en-US" altLang="zh-TW" sz="1600" b="1" dirty="0">
                 <a:solidFill>
                   <a:schemeClr val="dk1"/>
                 </a:solidFill>
-                <a:effectLst/>
-                <a:uFillTx/>
-                <a:latin typeface="Calibri"/>
-              </a:rPr>
-              <a:t>起來嗎</a:t>
-            </a:r>
-            <a:endParaRPr lang="en-US" sz="1800" b="0" u="none" strike="noStrike" dirty="0">
-              <a:solidFill>
-                <a:srgbClr val="000000"/>
-              </a:solidFill>
-              <a:effectLst/>
-              <a:uFillTx/>
-              <a:latin typeface="Arial"/>
+              </a:rPr>
+              <a:t>Microblock</a:t>
+            </a:r>
+            <a:r>
+              <a:rPr lang="zh-TW" altLang="en-US" sz="1600" b="1" dirty="0">
+                <a:solidFill>
+                  <a:schemeClr val="dk1"/>
+                </a:solidFill>
+              </a:rPr>
+              <a:t> </a:t>
+            </a:r>
+            <a:r>
+              <a:rPr lang="en-US" altLang="zh-TW" sz="1600" b="1" dirty="0" err="1">
+                <a:solidFill>
+                  <a:schemeClr val="dk1"/>
+                </a:solidFill>
+              </a:rPr>
+              <a:t>列出來</a:t>
+            </a:r>
+            <a:r>
+              <a:rPr lang="zh-TW" altLang="en-US" sz="1600" b="1" dirty="0">
+                <a:solidFill>
+                  <a:schemeClr val="dk1"/>
+                </a:solidFill>
+              </a:rPr>
+              <a:t> 然後</a:t>
+            </a:r>
+            <a:r>
+              <a:rPr lang="zh-TW" altLang="zh-TW" sz="1600" b="1" dirty="0">
+                <a:solidFill>
+                  <a:schemeClr val="dk1"/>
+                </a:solidFill>
+              </a:rPr>
+              <a:t>最佳化</a:t>
+            </a:r>
+            <a:endParaRPr lang="en-US" altLang="zh-TW" sz="1600" b="1" dirty="0">
+              <a:solidFill>
+                <a:schemeClr val="dk1"/>
+              </a:solidFill>
             </a:endParaRPr>
           </a:p>
           <a:p>
             <a:pPr marL="800280" lvl="1" indent="-343080" defTabSz="457200">
-              <a:lnSpc>
-                <a:spcPct val="100000"/>
-              </a:lnSpc>
               <a:buClr>
                 <a:srgbClr val="000000"/>
               </a:buClr>
@@ -8637,96 +9524,85 @@
               <a:buChar char=""/>
             </a:pPr>
             <a:r>
-              <a:rPr lang="zh-TW" sz="1800" b="1" u="none" strike="noStrike" dirty="0">
+              <a:rPr lang="en-US" altLang="zh-TW" sz="1600" b="1" dirty="0">
                 <a:solidFill>
                   <a:schemeClr val="dk1"/>
                 </a:solidFill>
-                <a:effectLst/>
-                <a:uFillTx/>
-                <a:latin typeface="Calibri"/>
-              </a:rPr>
-              <a:t>找出 </a:t>
-            </a:r>
-            <a:r>
-              <a:rPr lang="en-US" sz="1800" b="1" u="none" strike="noStrike" dirty="0">
+              </a:rPr>
+              <a:t>Check</a:t>
+            </a:r>
+            <a:r>
+              <a:rPr lang="zh-TW" altLang="en-US" sz="1600" b="1" dirty="0">
                 <a:solidFill>
                   <a:schemeClr val="dk1"/>
                 </a:solidFill>
-                <a:effectLst/>
-                <a:uFillTx/>
-                <a:latin typeface="Calibri"/>
-              </a:rPr>
-              <a:t>ETHZ_v6 pool/ewe </a:t>
-            </a:r>
-            <a:r>
-              <a:rPr lang="zh-TW" sz="1800" b="1" u="none" strike="noStrike" dirty="0">
+              </a:rPr>
+              <a:t> </a:t>
+            </a:r>
+            <a:r>
+              <a:rPr lang="en-US" altLang="zh-TW" sz="1600" b="1" dirty="0">
                 <a:solidFill>
                   <a:schemeClr val="dk1"/>
                 </a:solidFill>
-                <a:effectLst/>
-                <a:uFillTx/>
-                <a:latin typeface="Calibri"/>
-              </a:rPr>
-              <a:t>前後有 </a:t>
-            </a:r>
-            <a:r>
-              <a:rPr lang="en-US" sz="1800" b="1" u="none" strike="noStrike" dirty="0">
+              </a:rPr>
+              <a:t>ETHZ_V6 Flow</a:t>
+            </a:r>
+            <a:r>
+              <a:rPr lang="zh-TW" altLang="en-US" sz="1600" b="1" dirty="0">
                 <a:solidFill>
                   <a:schemeClr val="dk1"/>
                 </a:solidFill>
-                <a:effectLst/>
-                <a:uFillTx/>
-                <a:latin typeface="Calibri"/>
-              </a:rPr>
-              <a:t>CONV </a:t>
-            </a:r>
-            <a:r>
-              <a:rPr lang="zh-TW" sz="1800" b="1" u="none" strike="noStrike" dirty="0">
+              </a:rPr>
+              <a:t> 間 </a:t>
+            </a:r>
+            <a:r>
+              <a:rPr lang="en-US" altLang="zh-TW" sz="1600" b="1" dirty="0">
                 <a:solidFill>
                   <a:schemeClr val="dk1"/>
                 </a:solidFill>
-                <a:effectLst/>
-                <a:uFillTx/>
-                <a:latin typeface="Calibri"/>
-              </a:rPr>
-              <a:t>沒有 </a:t>
-            </a:r>
-            <a:r>
-              <a:rPr lang="en-US" sz="1800" b="1" u="none" strike="noStrike" dirty="0">
+              </a:rPr>
+              <a:t>Engine</a:t>
+            </a:r>
+            <a:r>
+              <a:rPr lang="zh-TW" altLang="en-US" sz="1600" b="1" dirty="0">
                 <a:solidFill>
                   <a:schemeClr val="dk1"/>
                 </a:solidFill>
-                <a:effectLst/>
-                <a:uFillTx/>
-                <a:latin typeface="Calibri"/>
-              </a:rPr>
-              <a:t>Overlap</a:t>
-            </a:r>
-            <a:r>
-              <a:rPr lang="zh-TW" sz="1800" b="1" u="none" strike="noStrike" dirty="0">
+              </a:rPr>
+              <a:t> 可以平行 沒有平行 </a:t>
+            </a:r>
+            <a:r>
+              <a:rPr lang="en-US" altLang="zh-TW" sz="1600" b="1" dirty="0" err="1">
                 <a:solidFill>
                   <a:schemeClr val="dk1"/>
                 </a:solidFill>
-                <a:effectLst/>
-                <a:uFillTx/>
-                <a:latin typeface="Calibri"/>
-              </a:rPr>
-              <a:t>找出來</a:t>
-            </a:r>
-            <a:endParaRPr lang="en-US" altLang="zh-TW" sz="1800" b="1" u="none" strike="noStrike" dirty="0">
+              </a:rPr>
+              <a:t>列出來</a:t>
+            </a:r>
+            <a:r>
+              <a:rPr lang="zh-TW" altLang="en-US" sz="1600" b="1" dirty="0">
+                <a:solidFill>
+                  <a:schemeClr val="dk1"/>
+                </a:solidFill>
+              </a:rPr>
+              <a:t> 然後</a:t>
+            </a:r>
+            <a:r>
+              <a:rPr lang="zh-TW" altLang="zh-TW" sz="1600" b="1" dirty="0">
+                <a:solidFill>
+                  <a:schemeClr val="dk1"/>
+                </a:solidFill>
+              </a:rPr>
+              <a:t>最佳化</a:t>
+            </a:r>
+            <a:endParaRPr lang="en-US" altLang="zh-TW" sz="1600" b="1" dirty="0">
               <a:solidFill>
                 <a:schemeClr val="dk1"/>
               </a:solidFill>
-              <a:effectLst/>
-              <a:uFillTx/>
-              <a:latin typeface="Calibri"/>
             </a:endParaRPr>
           </a:p>
           <a:p>
             <a:pPr marL="800280" lvl="1" indent="-343080" defTabSz="457200">
-              <a:lnSpc>
-                <a:spcPct val="100000"/>
-              </a:lnSpc>
               <a:buClr>
                 <a:srgbClr val="000000"/>
               </a:buClr>
@@ -8734,91 +9610,97 @@
               <a:buChar char=""/>
             </a:pPr>
             <a:r>
-              <a:rPr lang="en" altLang="zh-TW" b="1" dirty="0" err="1">
+              <a:rPr lang="en-US" altLang="zh-TW" sz="1600" b="1" dirty="0">
                 <a:solidFill>
                   <a:schemeClr val="dk1"/>
                 </a:solidFill>
-                <a:latin typeface="Calibri"/>
-              </a:rPr>
-              <a:t>xlsr_quant.tflite</a:t>
-            </a:r>
-            <a:r>
-              <a:rPr lang="en" altLang="zh-TW" b="1" dirty="0">
+              </a:rPr>
+              <a:t>Check</a:t>
+            </a:r>
+            <a:r>
+              <a:rPr lang="zh-TW" altLang="en-US" sz="1600" b="1" dirty="0">
                 <a:solidFill>
                   <a:schemeClr val="dk1"/>
                 </a:solidFill>
-                <a:latin typeface="Calibri"/>
-              </a:rPr>
-              <a:t> profile </a:t>
-            </a:r>
-            <a:r>
-              <a:rPr lang="zh-TW" altLang="en-US" b="1" dirty="0">
+              </a:rPr>
+              <a:t> </a:t>
+            </a:r>
+            <a:r>
+              <a:rPr lang="en-US" altLang="zh-TW" sz="1600" b="1" dirty="0">
                 <a:solidFill>
                   <a:schemeClr val="dk1"/>
                 </a:solidFill>
-                <a:latin typeface="Calibri"/>
+              </a:rPr>
+              <a:t>ETHZ_V6 Flow</a:t>
+            </a:r>
+            <a:r>
+              <a:rPr lang="zh-TW" altLang="en-US" sz="1600" b="1" dirty="0">
+                <a:solidFill>
+                  <a:schemeClr val="dk1"/>
+                </a:solidFill>
+              </a:rPr>
+              <a:t> 間 可以 </a:t>
+            </a:r>
+            <a:r>
+              <a:rPr lang="en-US" altLang="zh-TW" sz="1600" b="1" dirty="0" err="1">
+                <a:solidFill>
+                  <a:schemeClr val="dk1"/>
+                </a:solidFill>
+              </a:rPr>
+              <a:t>Prefecth</a:t>
+            </a:r>
+            <a:r>
+              <a:rPr lang="zh-TW" altLang="en-US" sz="1600" b="1" dirty="0">
+                <a:solidFill>
+                  <a:schemeClr val="dk1"/>
+                </a:solidFill>
+              </a:rPr>
+              <a:t> 沒有 </a:t>
+            </a:r>
+            <a:r>
+              <a:rPr lang="en-US" altLang="zh-TW" sz="1600" b="1" dirty="0" err="1">
+                <a:solidFill>
+                  <a:schemeClr val="dk1"/>
+                </a:solidFill>
+              </a:rPr>
+              <a:t>Prefecth</a:t>
+            </a:r>
+            <a:r>
+              <a:rPr lang="zh-TW" altLang="en-US" sz="1600" b="1" dirty="0">
+                <a:solidFill>
+                  <a:schemeClr val="dk1"/>
+                </a:solidFill>
               </a:rPr>
               <a:t> </a:t>
             </a:r>
             <a:r>
-              <a:rPr lang="en" altLang="zh-TW" b="1" dirty="0">
+              <a:rPr lang="en-US" altLang="zh-TW" sz="1600" b="1" dirty="0" err="1">
                 <a:solidFill>
                   <a:schemeClr val="dk1"/>
                 </a:solidFill>
-                <a:latin typeface="Calibri"/>
-              </a:rPr>
-              <a:t>L6 Conv </a:t>
-            </a:r>
-            <a:r>
-              <a:rPr lang="en" altLang="zh-TW" b="1" dirty="0" err="1">
+              </a:rPr>
+              <a:t>列出來</a:t>
+            </a:r>
+            <a:r>
+              <a:rPr lang="zh-TW" altLang="en-US" sz="1600" b="1" dirty="0">
                 <a:solidFill>
                   <a:schemeClr val="dk1"/>
                 </a:solidFill>
-                <a:latin typeface="Calibri"/>
-              </a:rPr>
-              <a:t>Micorbook</a:t>
-            </a:r>
-            <a:r>
-              <a:rPr lang="en" altLang="zh-TW" b="1" dirty="0">
+              </a:rPr>
+              <a:t> 然後</a:t>
+            </a:r>
+            <a:r>
+              <a:rPr lang="zh-TW" altLang="zh-TW" sz="1600" b="1" dirty="0">
                 <a:solidFill>
                   <a:schemeClr val="dk1"/>
                 </a:solidFill>
-                <a:latin typeface="Calibri"/>
-              </a:rPr>
-              <a:t> </a:t>
-            </a:r>
-            <a:r>
-              <a:rPr lang="zh-TW" altLang="en-US" b="1" dirty="0">
-                <a:solidFill>
-                  <a:schemeClr val="dk1"/>
-                </a:solidFill>
-                <a:latin typeface="Calibri"/>
-              </a:rPr>
-              <a:t>之間 還有 </a:t>
-            </a:r>
-            <a:r>
-              <a:rPr lang="en" altLang="zh-TW" b="1" dirty="0">
-                <a:solidFill>
-                  <a:schemeClr val="dk1"/>
-                </a:solidFill>
-                <a:latin typeface="Calibri"/>
-              </a:rPr>
-              <a:t>Bubble</a:t>
-            </a:r>
-            <a:r>
-              <a:rPr lang="zh-TW" altLang="en-US" b="1" dirty="0">
-                <a:solidFill>
-                  <a:schemeClr val="dk1"/>
-                </a:solidFill>
-                <a:latin typeface="Calibri"/>
-              </a:rPr>
-              <a:t>是什麼原因</a:t>
-            </a:r>
-            <a:endParaRPr lang="en-US" b="1" dirty="0">
+              </a:rPr>
+              <a:t>最佳化</a:t>
+            </a:r>
+            <a:endParaRPr lang="en-US" altLang="zh-TW" sz="1600" b="1" dirty="0">
               <a:solidFill>
                 <a:schemeClr val="dk1"/>
               </a:solidFill>
-              <a:latin typeface="Calibri"/>
             </a:endParaRPr>
           </a:p>
         </p:txBody>
@@ -8895,221 +9777,7 @@
 </p:sld>
 </file>
 
-<file path=ppt/slides/slide12.xml><?xml version="1.0" encoding="utf-8"?>
-<p:sld xmlns:a="http://schemas.openxmlformats.org/drawingml/2006/main" xmlns:r="http://schemas.openxmlformats.org/officeDocument/2006/relationships" xmlns:p="http://schemas.openxmlformats.org/presentationml/2006/main">
-  <p:cSld>
-    <p:spTree>
-      <p:nvGrpSpPr>
-        <p:cNvPr id="1" name=""/>
-        <p:cNvGrpSpPr/>
-        <p:nvPr/>
-      </p:nvGrpSpPr>
-      <p:grpSpPr>
-        <a:xfrm>
-          <a:off x="0" y="0"/>
-          <a:ext cx="0" cy="0"/>
-          <a:chOff x="0" y="0"/>
-          <a:chExt cx="0" cy="0"/>
-        </a:xfrm>
-      </p:grpSpPr>
-      <p:sp>
-        <p:nvSpPr>
-          <p:cNvPr id="201" name="TextBox 1"/>
-          <p:cNvSpPr/>
-          <p:nvPr/>
-        </p:nvSpPr>
-        <p:spPr>
-          <a:xfrm>
-            <a:off x="502920" y="255960"/>
-            <a:ext cx="7863480" cy="590400"/>
-          </a:xfrm>
-          <a:prstGeom prst="rect">
-            <a:avLst/>
-          </a:prstGeom>
-          <a:noFill/>
-          <a:ln w="0">
-            <a:noFill/>
-          </a:ln>
-        </p:spPr>
-        <p:style>
-          <a:lnRef idx="0">
-            <a:scrgbClr r="0" g="0" b="0"/>
-          </a:lnRef>
-          <a:fillRef idx="0">
-            <a:scrgbClr r="0" g="0" b="0"/>
-          </a:fillRef>
-          <a:effectRef idx="0">
-            <a:scrgbClr r="0" g="0" b="0"/>
-          </a:effectRef>
-          <a:fontRef idx="minor"/>
-        </p:style>
-        <p:txBody>
-          <a:bodyPr lIns="36720" tIns="18360" rIns="36720" bIns="18360" anchor="t">
-            <a:spAutoFit/>
-          </a:bodyPr>
-          <a:lstStyle/>
-          <a:p>
-            <a:pPr defTabSz="457200">
-              <a:lnSpc>
-                <a:spcPct val="100000"/>
-              </a:lnSpc>
-            </a:pPr>
-            <a:r>
-              <a:rPr lang="en-US" sz="3600" b="1" u="none" strike="noStrike" dirty="0">
-                <a:solidFill>
-                  <a:srgbClr val="183458"/>
-                </a:solidFill>
-                <a:effectLst/>
-                <a:uFillTx/>
-                <a:latin typeface="Calibri"/>
-              </a:rPr>
-              <a:t>Gap to Pipeline </a:t>
-            </a:r>
-            <a:r>
-              <a:rPr lang="en-US" altLang="zh-TW" sz="3600" b="1" u="none" strike="noStrike" dirty="0">
-                <a:solidFill>
-                  <a:srgbClr val="183458"/>
-                </a:solidFill>
-                <a:effectLst/>
-                <a:uFillTx/>
-                <a:latin typeface="Calibri"/>
-              </a:rPr>
-              <a:t>(to-do)</a:t>
-            </a:r>
-            <a:endParaRPr lang="en-US" sz="3600" b="0" u="none" strike="noStrike" dirty="0">
-              <a:solidFill>
-                <a:srgbClr val="000000"/>
-              </a:solidFill>
-              <a:effectLst/>
-              <a:uFillTx/>
-              <a:latin typeface="Arial"/>
-            </a:endParaRPr>
-          </a:p>
-        </p:txBody>
-      </p:sp>
-      <p:sp>
-        <p:nvSpPr>
-          <p:cNvPr id="202" name="Rectangle 3"/>
-          <p:cNvSpPr/>
-          <p:nvPr/>
-        </p:nvSpPr>
-        <p:spPr>
-          <a:xfrm>
-            <a:off x="502920" y="1024200"/>
-            <a:ext cx="11201040" cy="27000"/>
-          </a:xfrm>
-          <a:prstGeom prst="rect">
-            <a:avLst/>
-          </a:prstGeom>
-          <a:solidFill>
-            <a:srgbClr val="00897B"/>
-          </a:solidFill>
-          <a:ln>
-            <a:noFill/>
-          </a:ln>
-        </p:spPr>
-        <p:style>
-          <a:lnRef idx="1">
-            <a:schemeClr val="accent1"/>
-          </a:lnRef>
-          <a:fillRef idx="3">
-            <a:schemeClr val="accent1"/>
-          </a:fillRef>
-          <a:effectRef idx="2">
-            <a:schemeClr val="accent1"/>
-          </a:effectRef>
-          <a:fontRef idx="minor"/>
-        </p:style>
-        <p:txBody>
-          <a:bodyPr lIns="36720" tIns="13680" rIns="36720" bIns="13680" anchor="ctr">
-            <a:noAutofit/>
-          </a:bodyPr>
-          <a:lstStyle/>
-          <a:p>
-            <a:endParaRPr lang="en-US" sz="1800" b="0" u="none" strike="noStrike">
-              <a:solidFill>
-                <a:schemeClr val="lt1"/>
-              </a:solidFill>
-              <a:effectLst/>
-              <a:uFillTx/>
-              <a:latin typeface="Calibri"/>
-            </a:endParaRPr>
-          </a:p>
-        </p:txBody>
-      </p:sp>
-      <p:sp>
-        <p:nvSpPr>
-          <p:cNvPr id="215" name="TextBox 15"/>
-          <p:cNvSpPr/>
-          <p:nvPr/>
-        </p:nvSpPr>
-        <p:spPr>
-          <a:xfrm>
-            <a:off x="11064240" y="6446520"/>
-            <a:ext cx="639720" cy="228240"/>
-          </a:xfrm>
-          <a:prstGeom prst="rect">
-            <a:avLst/>
-          </a:prstGeom>
-          <a:noFill/>
-          <a:ln w="0">
-            <a:noFill/>
-          </a:ln>
-        </p:spPr>
-        <p:style>
-          <a:lnRef idx="0">
-            <a:scrgbClr r="0" g="0" b="0"/>
-          </a:lnRef>
-          <a:fillRef idx="0">
-            <a:scrgbClr r="0" g="0" b="0"/>
-          </a:fillRef>
-          <a:effectRef idx="0">
-            <a:scrgbClr r="0" g="0" b="0"/>
-          </a:effectRef>
-          <a:fontRef idx="minor"/>
-        </p:style>
-        <p:txBody>
-          <a:bodyPr lIns="36720" tIns="18360" rIns="36720" bIns="18360" anchor="t">
-            <a:spAutoFit/>
-          </a:bodyPr>
-          <a:lstStyle/>
-          <a:p>
-            <a:pPr algn="r" defTabSz="457200">
-              <a:lnSpc>
-                <a:spcPct val="100000"/>
-              </a:lnSpc>
-            </a:pPr>
-            <a:r>
-              <a:rPr lang="en-US" sz="800" b="0" u="none" strike="noStrike">
-                <a:solidFill>
-                  <a:srgbClr val="5E6875"/>
-                </a:solidFill>
-                <a:effectLst/>
-                <a:uFillTx/>
-                <a:latin typeface="Calibri"/>
-              </a:rPr>
-              <a:t>10</a:t>
-            </a:r>
-            <a:endParaRPr lang="en-US" sz="800" b="0" u="none" strike="noStrike">
-              <a:solidFill>
-                <a:srgbClr val="000000"/>
-              </a:solidFill>
-              <a:effectLst/>
-              <a:uFillTx/>
-              <a:latin typeface="Arial"/>
-            </a:endParaRPr>
-          </a:p>
-        </p:txBody>
-      </p:sp>
-    </p:spTree>
-  </p:cSld>
-  <p:clrMapOvr>
-    <a:masterClrMapping/>
-  </p:clrMapOvr>
-</p:sld>
-</file>
-
-<file path=ppt/slides/slide13.xml><?xml version="1.0" encoding="utf-8"?>
+<file path=ppt/slides/slide14.xml><?xml version="1.0" encoding="utf-8"?>
 <p:sld xmlns:a="http://schemas.openxmlformats.org/drawingml/2006/main" xmlns:r="http://schemas.openxmlformats.org/officeDocument/2006/relationships" xmlns:p="http://schemas.openxmlformats.org/presentationml/2006/main">
   <p:cSld>
     <p:spTree>
@@ -10633,31 +11301,7 @@
                 <a:latin typeface="Calibri"/>
                 <a:ea typeface="Noto Sans TC"/>
               </a:rPr>
-              <a:t>Output : E2E Function/</a:t>
-            </a:r>
-            <a:r>
-              <a:rPr lang="en-US" sz="2000" b="1" u="none" strike="noStrike" dirty="0" err="1">
-                <a:solidFill>
-                  <a:srgbClr val="183458"/>
-                </a:solidFill>
-                <a:effectLst/>
-                <a:uFillTx/>
-                <a:latin typeface="Calibri"/>
-                <a:ea typeface="Noto Sans TC"/>
-              </a:rPr>
-              <a:t>Peformance</a:t>
-            </a:r>
-            <a:r>
-              <a:rPr lang="en-US" sz="2000" b="1" u="none" strike="noStrike" dirty="0">
-                <a:solidFill>
-                  <a:srgbClr val="183458"/>
-                </a:solidFill>
-                <a:effectLst/>
-                <a:uFillTx/>
-                <a:latin typeface="Calibri"/>
-                <a:ea typeface="Noto Sans TC"/>
-              </a:rPr>
-              <a:t> Verification  (.</a:t>
+              <a:t>Output : E2E Function/Performance Verification  (.</a:t>
             </a:r>
             <a:r>
               <a:rPr lang="en-US" sz="2000" b="1" u="none" strike="noStrike" dirty="0" err="1">
@@ -17121,7 +17765,7 @@
                 </a:lnSpc>
               </a:pPr>
               <a:r>
-                <a:rPr lang="en-US" sz="1400" b="0" u="none" strike="noStrike">
+                <a:rPr lang="en-US" sz="1400" b="0" u="none" strike="noStrike" dirty="0">
                   <a:solidFill>
                     <a:srgbClr val="191C21"/>
                   </a:solidFill>
@@ -17129,9 +17773,31 @@
                   <a:uFillTx/>
                   <a:latin typeface="Calibri"/>
                 </a:rPr>
-                <a:t>LPDDR model peak ≈85.3 GB/s external</a:t>
+                <a:t>LPDDR</a:t>
               </a:r>
-              <a:endParaRPr lang="en-US" sz="1400" b="0" u="none" strike="noStrike">
+              <a:r>
+                <a:rPr lang="en-US" altLang="zh-TW" sz="1400" b="0" u="none" strike="noStrike" dirty="0">
+                  <a:solidFill>
+                    <a:srgbClr val="191C21"/>
+                  </a:solidFill>
+                  <a:effectLst/>
+                  <a:uFillTx/>
+                  <a:latin typeface="Calibri"/>
+                </a:rPr>
+                <a:t>5</a:t>
+              </a:r>
+              <a:r>
+                <a:rPr lang="en-US" sz="1400" b="0" u="none" strike="noStrike" dirty="0">
+                  <a:solidFill>
+                    <a:srgbClr val="191C21"/>
+                  </a:solidFill>
+                  <a:effectLst/>
+                  <a:uFillTx/>
+                  <a:latin typeface="Calibri"/>
+                </a:rPr>
+                <a:t> model peak ≈85.3 GB/s external</a:t>
+              </a:r>
+              <a:endParaRPr lang="en-US" sz="1400" b="0" u="none" strike="noStrike" dirty="0">
                 <a:solidFill>
                   <a:srgbClr val="000000"/>
                 </a:solidFill>
@@ -17469,7 +18135,7 @@
                 </a:lnSpc>
               </a:pPr>
               <a:r>
-                <a:rPr lang="en-US" sz="1400" b="0" u="none" strike="noStrike">
+                <a:rPr lang="en-US" sz="1400" b="0" u="none" strike="noStrike" dirty="0">
                   <a:solidFill>
                     <a:srgbClr val="191C21"/>
                   </a:solidFill>
@@ -17479,7 +18145,7 @@
                 </a:rPr>
                 <a:t>16 banks x 16B per SRAM cycle backend</a:t>
               </a:r>
-              <a:endParaRPr lang="en-US" sz="1400" b="0" u="none" strike="noStrike">
+              <a:endParaRPr lang="en-US" sz="1400" b="0" u="none" strike="noStrike" dirty="0">
                 <a:solidFill>
                   <a:srgbClr val="000000"/>
                 </a:solidFill>
@@ -18345,7 +19011,7 @@
             <a:p>
               <a:pPr algn="ctr"/>
               <a:r>
-                <a:rPr sz="2400" b="1">
+                <a:rPr sz="2400" b="1" dirty="0">
                   <a:solidFill>
                     <a:srgbClr val="475569"/>
                   </a:solidFill>
@@ -18756,6 +19422,24 @@
                 </a:solidFill>
                 <a:latin typeface="Calibri"/>
               </a:rPr>
+              <a:t>Pipeline</a:t>
+            </a:r>
+            <a:r>
+              <a:rPr lang="zh-TW" altLang="en-US" sz="3600" b="1" dirty="0">
+                <a:solidFill>
+                  <a:srgbClr val="183458"/>
+                </a:solidFill>
+                <a:latin typeface="Calibri"/>
+              </a:rPr>
+              <a:t> </a:t>
+            </a:r>
+            <a:r>
+              <a:rPr lang="en-US" altLang="zh-TW" sz="3600" b="1" dirty="0">
+                <a:solidFill>
+                  <a:srgbClr val="183458"/>
+                </a:solidFill>
+                <a:latin typeface="Calibri"/>
+              </a:rPr>
               <a:t>Path</a:t>
             </a:r>
             <a:r>
@@ -18856,7 +19540,7 @@
           <p:nvPr>
             <p:extLst>
               <p:ext uri="{D42A27DB-BD31-4B8C-83A1-F6EECF244321}">
-                <p14:modId xmlns:p14="http://schemas.microsoft.com/office/powerpoint/2010/main" val="1531783504"/>
+                <p14:modId xmlns:p14="http://schemas.microsoft.com/office/powerpoint/2010/main" val="2670633911"/>
               </p:ext>
             </p:extLst>
           </p:nvPr>
@@ -19122,7 +19806,7 @@
                           <a:effectLst/>
                           <a:latin typeface="+mn-lt"/>
                         </a:rPr>
-                        <a:t>1214</a:t>
+                        <a:t>44</a:t>
                       </a:r>
                       <a:endParaRPr lang="zh-TW" altLang="en-US" sz="1600" b="1" dirty="0">
                         <a:effectLst/>
@@ -19230,7 +19914,7 @@
                           <a:effectLst/>
                           <a:latin typeface="+mn-lt"/>
                         </a:rPr>
-                        <a:t>691</a:t>
+                        <a:t>52</a:t>
                       </a:r>
                       <a:endParaRPr lang="zh-TW" altLang="en-US" sz="1600" b="1" dirty="0">
                         <a:effectLst/>
@@ -19368,7 +20052,7 @@
                           <a:effectLst/>
                           <a:latin typeface="+mn-lt"/>
                         </a:rPr>
-                        <a:t>455</a:t>
+                        <a:t>286</a:t>
                       </a:r>
                     </a:p>
                   </a:txBody>
@@ -19472,7 +20156,7 @@
                           <a:effectLst/>
                           <a:latin typeface="+mn-lt"/>
                         </a:rPr>
-                        <a:t>198</a:t>
+                        <a:t>34</a:t>
                       </a:r>
                     </a:p>
                   </a:txBody>
@@ -19576,7 +20260,7 @@
                           <a:effectLst/>
                           <a:latin typeface="+mn-lt"/>
                         </a:rPr>
-                        <a:t>161</a:t>
+                        <a:t>9</a:t>
                       </a:r>
                     </a:p>
                   </a:txBody>
@@ -19690,7 +20374,7 @@
                           <a:effectLst/>
                           <a:latin typeface="+mn-lt"/>
                         </a:rPr>
-                        <a:t>125</a:t>
+                        <a:t>134</a:t>
                       </a:r>
                     </a:p>
                   </a:txBody>
@@ -20150,7 +20834,7 @@
                 </a:solidFill>
                 <a:latin typeface="Calibri"/>
               </a:rPr>
-              <a:t>Engine : Throughput TLM/ </a:t>
+              <a:t>Engines : Throughput TLM/ </a:t>
             </a:r>
             <a:r>
               <a:rPr lang="en-US" sz="2800" b="1" dirty="0">
@@ -20679,7 +21363,7 @@
                 <a:uFillTx/>
                 <a:latin typeface="Calibri"/>
               </a:rPr>
-              <a:t>SRAM Macro (1 Port R/W, 12K)</a:t>
+              <a:t>SRAM Macro (1 Port R/W, 768x16Bytes, 12K)</a:t>
             </a:r>
             <a:endParaRPr lang="en-US" sz="2400" b="0" u="none" strike="noStrike" dirty="0">
               <a:solidFill>
@@ -20834,29 +21518,7 @@
                 <a:uFillTx/>
                 <a:latin typeface="Calibri"/>
               </a:rPr>
-              <a:t>2Mesh4x4 mapping to same 16*Quad </a:t>
-            </a:r>
-            <a:r>
-              <a:rPr lang="en-US" sz="2400" b="1" u="none" strike="noStrike" dirty="0" err="1">
-                <a:solidFill>
-                  <a:srgbClr val="183458"/>
-                </a:solidFill>
-                <a:effectLst/>
-                <a:uFillTx/>
-                <a:latin typeface="Calibri"/>
-              </a:rPr>
-              <a:t>SrAM</a:t>
-            </a:r>
-            <a:r>
-              <a:rPr lang="en-US" sz="2400" b="1" u="none" strike="noStrike" dirty="0">
-                <a:solidFill>
-                  <a:srgbClr val="183458"/>
-                </a:solidFill>
-                <a:effectLst/>
-                <a:uFillTx/>
-                <a:latin typeface="Calibri"/>
-              </a:rPr>
-              <a:t> Macro</a:t>
+              <a:t>2xMesh4x4 mapping to same 16*Quad SRAM Macro</a:t>
             </a:r>
             <a:endParaRPr lang="en-US" sz="2400" b="0" u="none" strike="noStrike" dirty="0">
               <a:solidFill>
@@ -21159,7 +21821,7 @@
         </p:blipFill>
         <p:spPr>
           <a:xfrm>
-            <a:off x="1964520" y="76320"/>
+            <a:off x="2298627" y="76320"/>
             <a:ext cx="9739440" cy="6705360"/>
           </a:xfrm>
           <a:prstGeom prst="rect">

</xml_diff>

<commit_message>
Align L1Mesh spec and runner modes
</commit_message>
<xml_diff>
--- a/reports/uArcSim Implementation by AI.pptx
+++ b/reports/uArcSim Implementation by AI.pptx
@@ -20499,7 +20499,7 @@
         <p:spPr>
           <a:xfrm>
             <a:off x="901020" y="1404348"/>
-            <a:ext cx="10389960" cy="3545731"/>
+            <a:ext cx="10389960" cy="4284395"/>
           </a:xfrm>
           <a:prstGeom prst="rect">
             <a:avLst/>
@@ -20613,14 +20613,83 @@
               <a:buChar char=""/>
             </a:pPr>
             <a:r>
-              <a:rPr lang="en-US" altLang="zh-TW" sz="3600" b="1" dirty="0">
+              <a:rPr lang="en-US" altLang="zh-TW" sz="2800" b="1" dirty="0">
                 <a:solidFill>
                   <a:srgbClr val="183458"/>
                 </a:solidFill>
                 <a:latin typeface="Arial"/>
               </a:rPr>
+              <a:t>Find</a:t>
+            </a:r>
+            <a:r>
+              <a:rPr lang="zh-TW" altLang="en-US" sz="2800" b="1" dirty="0">
+                <a:solidFill>
+                  <a:srgbClr val="183458"/>
+                </a:solidFill>
+                <a:latin typeface="Arial"/>
+              </a:rPr>
               <a:t> </a:t>
             </a:r>
+            <a:r>
+              <a:rPr lang="en-US" altLang="zh-TW" sz="2800" b="1" dirty="0">
+                <a:solidFill>
+                  <a:srgbClr val="183458"/>
+                </a:solidFill>
+                <a:latin typeface="Arial"/>
+              </a:rPr>
+              <a:t>Gap of FE/IA/</a:t>
+            </a:r>
+            <a:r>
+              <a:rPr lang="en-US" altLang="zh-TW" sz="2800" b="1">
+                <a:solidFill>
+                  <a:srgbClr val="183458"/>
+                </a:solidFill>
+                <a:latin typeface="Arial"/>
+              </a:rPr>
+              <a:t>CX speed with simulator designed </a:t>
+            </a:r>
+            <a:r>
+              <a:rPr lang="en-US" altLang="zh-TW" sz="2800" b="1" dirty="0" err="1">
+                <a:solidFill>
+                  <a:srgbClr val="183458"/>
+                </a:solidFill>
+                <a:latin typeface="Arial"/>
+              </a:rPr>
+              <a:t>byAI</a:t>
+            </a:r>
+            <a:r>
+              <a:rPr lang="en-US" altLang="zh-TW" sz="2800" b="1" dirty="0">
+                <a:solidFill>
+                  <a:srgbClr val="183458"/>
+                </a:solidFill>
+                <a:latin typeface="Arial"/>
+              </a:rPr>
+              <a:t>  </a:t>
+            </a:r>
+          </a:p>
+          <a:p>
+            <a:pPr marL="343080" indent="-343080" defTabSz="457200">
+              <a:buClr>
+                <a:srgbClr val="183458"/>
+              </a:buClr>
+              <a:buFont typeface="Wingdings" charset="2"/>
+              <a:buChar char=""/>
+            </a:pPr>
+            <a:endParaRPr lang="en-US" altLang="zh-TW" sz="2800" b="1" dirty="0">
+              <a:solidFill>
+                <a:srgbClr val="183458"/>
+              </a:solidFill>
+              <a:latin typeface="Arial"/>
+            </a:endParaRPr>
+          </a:p>
+          <a:p>
+            <a:pPr marL="343080" indent="-343080" defTabSz="457200">
+              <a:buClr>
+                <a:srgbClr val="183458"/>
+              </a:buClr>
+              <a:buFont typeface="Wingdings" charset="2"/>
+              <a:buChar char=""/>
+            </a:pPr>
             <a:r>
               <a:rPr lang="en-US" altLang="zh-TW" sz="2800" b="1" dirty="0">
                 <a:solidFill>
@@ -20680,23 +20749,8 @@
                 </a:solidFill>
                 <a:latin typeface="Arial"/>
               </a:rPr>
-              <a:t>MVPU </a:t>
-            </a:r>
-            <a:r>
-              <a:rPr lang="en-US" sz="2800" b="1">
-                <a:solidFill>
-                  <a:srgbClr val="183458"/>
-                </a:solidFill>
-                <a:latin typeface="Arial"/>
-              </a:rPr>
-              <a:t>2.5 System</a:t>
-            </a:r>
-            <a:endParaRPr lang="en-US" sz="2800" b="1" dirty="0">
-              <a:solidFill>
-                <a:srgbClr val="183458"/>
-              </a:solidFill>
-              <a:latin typeface="Arial"/>
-            </a:endParaRPr>
+              <a:t>MVPU 2.5 System</a:t>
+            </a:r>
           </a:p>
         </p:txBody>
       </p:sp>
@@ -27179,7 +27233,7 @@
                 </a:lnSpc>
               </a:pPr>
               <a:r>
-                <a:rPr lang="en-US" sz="1600" b="1" u="none" strike="noStrike">
+                <a:rPr lang="en-US" sz="1600" b="1" u="none" strike="noStrike" dirty="0">
                   <a:solidFill>
                     <a:srgbClr val="FFFFFF"/>
                   </a:solidFill>
@@ -27189,7 +27243,7 @@
                 </a:rPr>
                 <a:t>Module</a:t>
               </a:r>
-              <a:endParaRPr lang="en-US" sz="1600" b="0" u="none" strike="noStrike">
+              <a:endParaRPr lang="en-US" sz="1600" b="0" u="none" strike="noStrike" dirty="0">
                 <a:solidFill>
                   <a:srgbClr val="000000"/>
                 </a:solidFill>
@@ -27527,7 +27581,7 @@
                 </a:lnSpc>
               </a:pPr>
               <a:r>
-                <a:rPr lang="en-US" sz="1400" b="0" u="none" strike="noStrike">
+                <a:rPr lang="en-US" sz="1400" b="0" u="none" strike="noStrike" dirty="0">
                   <a:solidFill>
                     <a:srgbClr val="191C21"/>
                   </a:solidFill>
@@ -27537,7 +27591,7 @@
                 </a:rPr>
                 <a:t>CONV</a:t>
               </a:r>
-              <a:endParaRPr lang="en-US" sz="1400" b="0" u="none" strike="noStrike">
+              <a:endParaRPr lang="en-US" sz="1400" b="0" u="none" strike="noStrike" dirty="0">
                 <a:solidFill>
                   <a:srgbClr val="000000"/>
                 </a:solidFill>
@@ -27759,7 +27813,7 @@
                 </a:lnSpc>
               </a:pPr>
               <a:r>
-                <a:rPr lang="en-US" sz="1400" b="0" u="none" strike="noStrike">
+                <a:rPr lang="en-US" sz="1400" b="0" u="none" strike="noStrike" dirty="0">
                   <a:solidFill>
                     <a:srgbClr val="191C21"/>
                   </a:solidFill>
@@ -27767,9 +27821,31 @@
                   <a:uFillTx/>
                   <a:latin typeface="Calibri"/>
                 </a:rPr>
-                <a:t>INT8x8: 16,384 MAC/cyc; 62.3 TOPS @1.9GHz</a:t>
+                <a:t>INT8x8: 16,384 MAC/</a:t>
               </a:r>
-              <a:endParaRPr lang="en-US" sz="1400" b="0" u="none" strike="noStrike">
+              <a:r>
+                <a:rPr lang="en-US" sz="1400" b="0" u="none" strike="noStrike" dirty="0" err="1">
+                  <a:solidFill>
+                    <a:srgbClr val="191C21"/>
+                  </a:solidFill>
+                  <a:effectLst/>
+                  <a:uFillTx/>
+                  <a:latin typeface="Calibri"/>
+                </a:rPr>
+                <a:t>cyc</a:t>
+              </a:r>
+              <a:r>
+                <a:rPr lang="en-US" sz="1400" b="0" u="none" strike="noStrike" dirty="0">
+                  <a:solidFill>
+                    <a:srgbClr val="191C21"/>
+                  </a:solidFill>
+                  <a:effectLst/>
+                  <a:uFillTx/>
+                  <a:latin typeface="Calibri"/>
+                </a:rPr>
+                <a:t>; 62.3 TOPS @1.9GHz</a:t>
+              </a:r>
+              <a:endParaRPr lang="en-US" sz="1400" b="0" u="none" strike="noStrike" dirty="0">
                 <a:solidFill>
                   <a:srgbClr val="000000"/>
                 </a:solidFill>

</xml_diff>

<commit_message>
Add qwen35 attention TFLite models and update presentation
qwen35_attention_s{128,1024}.tflite: single-step decode attention
models at rope position 128 and 1024 (used in BMM regression).

Co-Authored-By: Claude Sonnet 4.6 <noreply@anthropic.com>
</commit_message>
<xml_diff>
--- a/reports/uArcSim Implementation by AI.pptx
+++ b/reports/uArcSim Implementation by AI.pptx
@@ -1662,7 +1662,7 @@
           <a:p>
             <a:fld id="{5BCAD085-E8A6-8845-BD4E-CB4CCA059FC4}" type="datetimeFigureOut">
               <a:rPr lang="en-US" smtClean="0"/>
-              <a:t>5/13/26</a:t>
+              <a:t>5/14/26</a:t>
             </a:fld>
             <a:endParaRPr lang="en-US"/>
           </a:p>
@@ -18010,7 +18010,7 @@
                   <a:srgbClr val="183458"/>
                 </a:solidFill>
               </a:rPr>
-              <a:t>Harass</a:t>
+              <a:t>Harness</a:t>
             </a:r>
             <a:r>
               <a:rPr lang="zh-TW" altLang="en-US" sz="3600" b="1" dirty="0">
@@ -18234,7 +18234,7 @@
                 </a:solidFill>
                 <a:latin typeface="Calibri"/>
               </a:rPr>
-              <a:t>MDLA7</a:t>
+              <a:t>DLA7</a:t>
             </a:r>
             <a:r>
               <a:rPr lang="zh-TW" altLang="en-US" sz="2000" b="1" dirty="0">
@@ -19051,7 +19051,7 @@
               <a:buChar char=""/>
             </a:pPr>
             <a:r>
-              <a:rPr lang="en-US" altLang="zh-TW" sz="3200" b="1">
+              <a:rPr lang="en-US" altLang="zh-TW" sz="3200" b="1" dirty="0" err="1">
                 <a:solidFill>
                   <a:srgbClr val="183458"/>
                 </a:solidFill>
@@ -19161,7 +19161,7 @@
                 </a:solidFill>
                 <a:latin typeface="Calibri"/>
               </a:rPr>
-              <a:t>AI Harass Engineering</a:t>
+              <a:t>AI Harness Engineering</a:t>
             </a:r>
           </a:p>
           <a:p>

</xml_diff>

<commit_message>
Session 5: EWE×4/POOL×2 scaling, P3 pipeline, UDMA prefetch, transformer docs
Hardware scaling:
- EWE ×4 (FP 32→128 lanes, INT8 64→256) + matching BW (EWE_R×2, EWE_W×4)
- POOL ×2 (independent POOL_FP/INT8 lane constants, POOL_R×2, POOL_W×2)
- CX baseline 16 ms → 3.6 ms (4.4×) on bmm_softmax_bmm_tiled_2.5ms_int8

P3 CONV/EWE/POOL microblock pipeline (from previous session):
- store_barrier removed on pipelined BMM to unblock SM dispatch
- UDMA_R weight prefetch: emit next BMM's wgt load (wait=0) during SM chain;
  CONV starts 597 cycles earlier per block

Model / doc housekeeping:
- Add bmm_softmax_bmm_tiled_2.5ms_int8.tflite (tiled stress model)
- Remove retired FP16 kvcache and legacy BMM tflite files
- Add transformer.md, drawio/ diagrams (RNN→Attention, flow, block, FFN, MDLA7)
- Add analysis scripts (diff_attention_profiles, gen_softmax_pptx, etc.)
- Update handoff.md, L1Mesh_report.md, compile_model.py, run_systemc.py

Co-Authored-By: Claude Sonnet 4.6 <noreply@anthropic.com>
</commit_message>
<xml_diff>
--- a/reports/uArcSim Implementation by AI.pptx
+++ b/reports/uArcSim Implementation by AI.pptx
@@ -25,6 +25,8 @@
     <p:sldId id="273" r:id="rId19"/>
     <p:sldId id="277" r:id="rId20"/>
     <p:sldId id="280" r:id="rId21"/>
+    <p:sldId id="283" r:id="rId22"/>
+    <p:sldId id="284" r:id="rId23"/>
   </p:sldIdLst>
   <p:sldSz cx="12192000" cy="6858000"/>
   <p:notesSz cx="7559675" cy="10691813"/>
@@ -1662,7 +1664,7 @@
           <a:p>
             <a:fld id="{5BCAD085-E8A6-8845-BD4E-CB4CCA059FC4}" type="datetimeFigureOut">
               <a:rPr lang="en-US" smtClean="0"/>
-              <a:t>5/14/26</a:t>
+              <a:t>5/15/26</a:t>
             </a:fld>
             <a:endParaRPr lang="en-US"/>
           </a:p>
@@ -19786,6 +19788,776 @@
 </p:sld>
 </file>
 
+<file path=ppt/slides/slide21.xml><?xml version="1.0" encoding="utf-8"?>
+<p:sld xmlns:a="http://schemas.openxmlformats.org/drawingml/2006/main" xmlns:r="http://schemas.openxmlformats.org/officeDocument/2006/relationships" xmlns:p="http://schemas.openxmlformats.org/presentationml/2006/main">
+  <p:cSld>
+    <p:spTree>
+      <p:nvGrpSpPr>
+        <p:cNvPr id="1" name=""/>
+        <p:cNvGrpSpPr/>
+        <p:nvPr/>
+      </p:nvGrpSpPr>
+      <p:grpSpPr>
+        <a:xfrm>
+          <a:off x="0" y="0"/>
+          <a:ext cx="0" cy="0"/>
+          <a:chOff x="0" y="0"/>
+          <a:chExt cx="0" cy="0"/>
+        </a:xfrm>
+      </p:grpSpPr>
+      <p:sp>
+        <p:nvSpPr>
+          <p:cNvPr id="3" name="文字版面配置區 2">
+            <a:extLst>
+              <a:ext uri="{FF2B5EF4-FFF2-40B4-BE49-F238E27FC236}">
+                <a16:creationId xmlns:a16="http://schemas.microsoft.com/office/drawing/2014/main" id="{2C3EB85A-644F-E165-581D-4D9EC73A7016}"/>
+              </a:ext>
+            </a:extLst>
+          </p:cNvPr>
+          <p:cNvSpPr>
+            <a:spLocks noGrp="1"/>
+          </p:cNvSpPr>
+          <p:nvPr>
+            <p:ph type="body"/>
+          </p:nvPr>
+        </p:nvSpPr>
+        <p:spPr>
+          <a:xfrm>
+            <a:off x="359736" y="1115423"/>
+            <a:ext cx="4765158" cy="1829796"/>
+          </a:xfrm>
+        </p:spPr>
+        <p:txBody>
+          <a:bodyPr>
+            <a:normAutofit/>
+          </a:bodyPr>
+          <a:lstStyle/>
+          <a:p>
+            <a:r>
+              <a:rPr lang="zh-TW" altLang="zh-TW" sz="1050" b="1" dirty="0"/>
+              <a:t>MDLA7 profile — bmm_softmax_bmm_2.5ms_1g_int8.tflite (fast)</a:t>
+            </a:r>
+          </a:p>
+          <a:p>
+            <a:r>
+              <a:rPr lang="zh-TW" altLang="zh-TW" sz="1050" b="1" dirty="0"/>
+              <a:t>Model:</a:t>
+            </a:r>
+            <a:r>
+              <a:rPr lang="zh-TW" altLang="zh-TW" sz="1050" dirty="0"/>
+              <a:t> model/BMM/bmm_softmax_bmm_2.5ms_1g_int8.tflite</a:t>
+            </a:r>
+            <a:endParaRPr lang="en-US" altLang="zh-TW" sz="1050" dirty="0"/>
+          </a:p>
+          <a:p>
+            <a:r>
+              <a:rPr lang="zh-TW" altLang="zh-TW" sz="1050" b="1" dirty="0"/>
+              <a:t>Compiled layers:</a:t>
+            </a:r>
+            <a:r>
+              <a:rPr lang="zh-TW" altLang="zh-TW" sz="1050" dirty="0"/>
+              <a:t> 65 (PASS 63 / FAIL 2)</a:t>
+            </a:r>
+            <a:endParaRPr lang="en-US" altLang="zh-TW" sz="1050" dirty="0"/>
+          </a:p>
+          <a:p>
+            <a:r>
+              <a:rPr lang="zh-TW" altLang="zh-TW" sz="1050" b="1" dirty="0"/>
+              <a:t>Graph coverage:</a:t>
+            </a:r>
+            <a:r>
+              <a:rPr lang="zh-TW" altLang="zh-TW" sz="1050" dirty="0"/>
+              <a:t> complete — 0/65 compile rows skipped</a:t>
+            </a:r>
+            <a:endParaRPr lang="en-US" altLang="zh-TW" sz="1050" dirty="0"/>
+          </a:p>
+          <a:p>
+            <a:r>
+              <a:rPr lang="zh-TW" altLang="zh-TW" sz="1050" b="1" dirty="0"/>
+              <a:t>Verification:</a:t>
+            </a:r>
+            <a:r>
+              <a:rPr lang="zh-TW" altLang="zh-TW" sz="1050" dirty="0"/>
+              <a:t> per compiled-layer DRAM reference compare, including the final compiled layer; no separate original-TFLite final-output checker</a:t>
+            </a:r>
+            <a:endParaRPr lang="en-US" altLang="zh-TW" sz="1050" dirty="0"/>
+          </a:p>
+          <a:p>
+            <a:r>
+              <a:rPr lang="zh-TW" altLang="zh-TW" sz="1050" b="1" dirty="0"/>
+              <a:t>Sim time:</a:t>
+            </a:r>
+            <a:r>
+              <a:rPr lang="zh-TW" altLang="zh-TW" sz="1050" dirty="0"/>
+              <a:t> 5.749 ms @ 1.9 GHz (10,923,659 cycles)</a:t>
+            </a:r>
+            <a:endParaRPr lang="en-US" altLang="zh-TW" sz="1050" dirty="0"/>
+          </a:p>
+          <a:p>
+            <a:r>
+              <a:rPr lang="zh-TW" altLang="zh-TW" sz="1050" b="1" dirty="0"/>
+              <a:t>Util:</a:t>
+            </a:r>
+            <a:r>
+              <a:rPr lang="zh-TW" altLang="zh-TW" sz="1050" dirty="0"/>
+              <a:t> avg 24.4% / peak 55.4% (udma_w)</a:t>
+            </a:r>
+            <a:endParaRPr lang="en-US" altLang="zh-TW" sz="1050" dirty="0"/>
+          </a:p>
+          <a:p>
+            <a:r>
+              <a:rPr lang="zh-TW" altLang="zh-TW" sz="1050" b="1" dirty="0"/>
+              <a:t>DRAM r/w:</a:t>
+            </a:r>
+            <a:r>
+              <a:rPr lang="zh-TW" altLang="zh-TW" sz="1050" dirty="0"/>
+              <a:t> 142.58 / 276.82 MB</a:t>
+            </a:r>
+            <a:endParaRPr lang="en-US" altLang="zh-TW" sz="1050" dirty="0"/>
+          </a:p>
+          <a:p>
+            <a:r>
+              <a:rPr lang="zh-TW" altLang="zh-TW" sz="1050" b="1" dirty="0"/>
+              <a:t>SRAM r/w:</a:t>
+            </a:r>
+            <a:r>
+              <a:rPr lang="zh-TW" altLang="zh-TW" sz="1050" dirty="0"/>
+              <a:t> 672.29 / 579.44 MB</a:t>
+            </a:r>
+          </a:p>
+          <a:p>
+            <a:endParaRPr kumimoji="1" lang="zh-TW" altLang="en-US" sz="1050" dirty="0"/>
+          </a:p>
+        </p:txBody>
+      </p:sp>
+      <p:pic>
+        <p:nvPicPr>
+          <p:cNvPr id="6" name="圖片 5">
+            <a:extLst>
+              <a:ext uri="{FF2B5EF4-FFF2-40B4-BE49-F238E27FC236}">
+                <a16:creationId xmlns:a16="http://schemas.microsoft.com/office/drawing/2014/main" id="{9486EDF1-5FDA-9C0B-9BFB-9AA773573FDA}"/>
+              </a:ext>
+            </a:extLst>
+          </p:cNvPr>
+          <p:cNvPicPr>
+            <a:picLocks noChangeAspect="1"/>
+          </p:cNvPicPr>
+          <p:nvPr/>
+        </p:nvPicPr>
+        <p:blipFill>
+          <a:blip r:embed="rId2"/>
+          <a:stretch>
+            <a:fillRect/>
+          </a:stretch>
+        </p:blipFill>
+        <p:spPr>
+          <a:xfrm>
+            <a:off x="3824753" y="2351327"/>
+            <a:ext cx="7772400" cy="4077530"/>
+          </a:xfrm>
+          <a:prstGeom prst="rect">
+            <a:avLst/>
+          </a:prstGeom>
+        </p:spPr>
+      </p:pic>
+      <p:sp>
+        <p:nvSpPr>
+          <p:cNvPr id="7" name="TextBox 1">
+            <a:extLst>
+              <a:ext uri="{FF2B5EF4-FFF2-40B4-BE49-F238E27FC236}">
+                <a16:creationId xmlns:a16="http://schemas.microsoft.com/office/drawing/2014/main" id="{CADD0CD7-53CD-4B28-976C-745C8EF1CF92}"/>
+              </a:ext>
+            </a:extLst>
+          </p:cNvPr>
+          <p:cNvSpPr/>
+          <p:nvPr/>
+        </p:nvSpPr>
+        <p:spPr>
+          <a:xfrm>
+            <a:off x="747000" y="180360"/>
+            <a:ext cx="7863480" cy="651960"/>
+          </a:xfrm>
+          <a:prstGeom prst="rect">
+            <a:avLst/>
+          </a:prstGeom>
+          <a:noFill/>
+          <a:ln w="0">
+            <a:noFill/>
+          </a:ln>
+        </p:spPr>
+        <p:style>
+          <a:lnRef idx="0">
+            <a:scrgbClr r="0" g="0" b="0"/>
+          </a:lnRef>
+          <a:fillRef idx="0">
+            <a:scrgbClr r="0" g="0" b="0"/>
+          </a:fillRef>
+          <a:effectRef idx="0">
+            <a:scrgbClr r="0" g="0" b="0"/>
+          </a:effectRef>
+          <a:fontRef idx="minor"/>
+        </p:style>
+        <p:txBody>
+          <a:bodyPr lIns="36720" tIns="18360" rIns="36720" bIns="18360" anchor="t">
+            <a:spAutoFit/>
+          </a:bodyPr>
+          <a:lstStyle/>
+          <a:p>
+            <a:pPr defTabSz="457200">
+              <a:lnSpc>
+                <a:spcPct val="100000"/>
+              </a:lnSpc>
+            </a:pPr>
+            <a:r>
+              <a:rPr lang="en-US" sz="4000" b="1" dirty="0">
+                <a:solidFill>
+                  <a:srgbClr val="183458"/>
+                </a:solidFill>
+                <a:latin typeface="Calibri"/>
+              </a:rPr>
+              <a:t>BMM-</a:t>
+            </a:r>
+            <a:r>
+              <a:rPr lang="en-US" sz="4000" b="1" dirty="0" err="1">
+                <a:solidFill>
+                  <a:srgbClr val="183458"/>
+                </a:solidFill>
+                <a:latin typeface="Calibri"/>
+              </a:rPr>
+              <a:t>Softmax</a:t>
+            </a:r>
+            <a:r>
+              <a:rPr lang="en-US" sz="4000" b="1" dirty="0">
+                <a:solidFill>
+                  <a:srgbClr val="183458"/>
+                </a:solidFill>
+                <a:latin typeface="Calibri"/>
+              </a:rPr>
+              <a:t>-BMM </a:t>
+            </a:r>
+            <a:r>
+              <a:rPr lang="en-US" sz="4000" b="1" dirty="0" err="1">
+                <a:solidFill>
+                  <a:srgbClr val="183458"/>
+                </a:solidFill>
+                <a:latin typeface="Calibri"/>
+              </a:rPr>
+              <a:t>第一版</a:t>
+            </a:r>
+            <a:endParaRPr lang="en-US" sz="4000" b="0" u="none" strike="noStrike" dirty="0">
+              <a:solidFill>
+                <a:srgbClr val="000000"/>
+              </a:solidFill>
+              <a:effectLst/>
+              <a:uFillTx/>
+              <a:latin typeface="Arial"/>
+            </a:endParaRPr>
+          </a:p>
+        </p:txBody>
+      </p:sp>
+      <p:sp>
+        <p:nvSpPr>
+          <p:cNvPr id="8" name="Rectangle 3">
+            <a:extLst>
+              <a:ext uri="{FF2B5EF4-FFF2-40B4-BE49-F238E27FC236}">
+                <a16:creationId xmlns:a16="http://schemas.microsoft.com/office/drawing/2014/main" id="{92BBC1C9-8392-7116-B0C1-1BF64D33C241}"/>
+              </a:ext>
+            </a:extLst>
+          </p:cNvPr>
+          <p:cNvSpPr/>
+          <p:nvPr/>
+        </p:nvSpPr>
+        <p:spPr>
+          <a:xfrm>
+            <a:off x="495480" y="861236"/>
+            <a:ext cx="11201040" cy="27000"/>
+          </a:xfrm>
+          <a:prstGeom prst="rect">
+            <a:avLst/>
+          </a:prstGeom>
+          <a:solidFill>
+            <a:srgbClr val="00897B"/>
+          </a:solidFill>
+          <a:ln>
+            <a:noFill/>
+          </a:ln>
+        </p:spPr>
+        <p:style>
+          <a:lnRef idx="1">
+            <a:schemeClr val="accent1"/>
+          </a:lnRef>
+          <a:fillRef idx="3">
+            <a:schemeClr val="accent1"/>
+          </a:fillRef>
+          <a:effectRef idx="2">
+            <a:schemeClr val="accent1"/>
+          </a:effectRef>
+          <a:fontRef idx="minor"/>
+        </p:style>
+        <p:txBody>
+          <a:bodyPr lIns="36720" tIns="13680" rIns="36720" bIns="13680" anchor="ctr">
+            <a:noAutofit/>
+          </a:bodyPr>
+          <a:lstStyle/>
+          <a:p>
+            <a:endParaRPr lang="en-US" sz="1800" b="0" u="none" strike="noStrike">
+              <a:solidFill>
+                <a:schemeClr val="lt1"/>
+              </a:solidFill>
+              <a:effectLst/>
+              <a:uFillTx/>
+              <a:latin typeface="Calibri"/>
+            </a:endParaRPr>
+          </a:p>
+        </p:txBody>
+      </p:sp>
+      <p:pic>
+        <p:nvPicPr>
+          <p:cNvPr id="11" name="圖片 10">
+            <a:extLst>
+              <a:ext uri="{FF2B5EF4-FFF2-40B4-BE49-F238E27FC236}">
+                <a16:creationId xmlns:a16="http://schemas.microsoft.com/office/drawing/2014/main" id="{90661994-4311-89B3-4258-54359F100C2C}"/>
+              </a:ext>
+            </a:extLst>
+          </p:cNvPr>
+          <p:cNvPicPr>
+            <a:picLocks noChangeAspect="1"/>
+          </p:cNvPicPr>
+          <p:nvPr/>
+        </p:nvPicPr>
+        <p:blipFill>
+          <a:blip r:embed="rId3">
+            <a:extLst>
+              <a:ext uri="{28A0092B-C50C-407E-A947-70E740481C1C}">
+                <a14:useLocalDpi xmlns:a14="http://schemas.microsoft.com/office/drawing/2010/main" val="0"/>
+              </a:ext>
+            </a:extLst>
+          </a:blip>
+          <a:stretch>
+            <a:fillRect/>
+          </a:stretch>
+        </p:blipFill>
+        <p:spPr>
+          <a:xfrm>
+            <a:off x="594847" y="3172406"/>
+            <a:ext cx="2998766" cy="3100803"/>
+          </a:xfrm>
+          <a:prstGeom prst="rect">
+            <a:avLst/>
+          </a:prstGeom>
+        </p:spPr>
+      </p:pic>
+    </p:spTree>
+    <p:extLst>
+      <p:ext uri="{BB962C8B-B14F-4D97-AF65-F5344CB8AC3E}">
+        <p14:creationId xmlns:p14="http://schemas.microsoft.com/office/powerpoint/2010/main" val="2380276987"/>
+      </p:ext>
+    </p:extLst>
+  </p:cSld>
+  <p:clrMapOvr>
+    <a:masterClrMapping/>
+  </p:clrMapOvr>
+</p:sld>
+</file>
+
+<file path=ppt/slides/slide22.xml><?xml version="1.0" encoding="utf-8"?>
+<p:sld xmlns:a="http://schemas.openxmlformats.org/drawingml/2006/main" xmlns:r="http://schemas.openxmlformats.org/officeDocument/2006/relationships" xmlns:p="http://schemas.openxmlformats.org/presentationml/2006/main">
+  <p:cSld>
+    <p:spTree>
+      <p:nvGrpSpPr>
+        <p:cNvPr id="1" name="">
+          <a:extLst>
+            <a:ext uri="{FF2B5EF4-FFF2-40B4-BE49-F238E27FC236}">
+              <a16:creationId xmlns:a16="http://schemas.microsoft.com/office/drawing/2014/main" id="{EF0DA066-1F48-B107-A569-F54AC95548CD}"/>
+            </a:ext>
+          </a:extLst>
+        </p:cNvPr>
+        <p:cNvGrpSpPr/>
+        <p:nvPr/>
+      </p:nvGrpSpPr>
+      <p:grpSpPr>
+        <a:xfrm>
+          <a:off x="0" y="0"/>
+          <a:ext cx="0" cy="0"/>
+          <a:chOff x="0" y="0"/>
+          <a:chExt cx="0" cy="0"/>
+        </a:xfrm>
+      </p:grpSpPr>
+      <p:sp>
+        <p:nvSpPr>
+          <p:cNvPr id="7" name="TextBox 1">
+            <a:extLst>
+              <a:ext uri="{FF2B5EF4-FFF2-40B4-BE49-F238E27FC236}">
+                <a16:creationId xmlns:a16="http://schemas.microsoft.com/office/drawing/2014/main" id="{98DCE16D-9BD9-5075-B812-01712550B96B}"/>
+              </a:ext>
+            </a:extLst>
+          </p:cNvPr>
+          <p:cNvSpPr/>
+          <p:nvPr/>
+        </p:nvSpPr>
+        <p:spPr>
+          <a:xfrm>
+            <a:off x="747000" y="180360"/>
+            <a:ext cx="7863480" cy="651960"/>
+          </a:xfrm>
+          <a:prstGeom prst="rect">
+            <a:avLst/>
+          </a:prstGeom>
+          <a:noFill/>
+          <a:ln w="0">
+            <a:noFill/>
+          </a:ln>
+        </p:spPr>
+        <p:style>
+          <a:lnRef idx="0">
+            <a:scrgbClr r="0" g="0" b="0"/>
+          </a:lnRef>
+          <a:fillRef idx="0">
+            <a:scrgbClr r="0" g="0" b="0"/>
+          </a:fillRef>
+          <a:effectRef idx="0">
+            <a:scrgbClr r="0" g="0" b="0"/>
+          </a:effectRef>
+          <a:fontRef idx="minor"/>
+        </p:style>
+        <p:txBody>
+          <a:bodyPr lIns="36720" tIns="18360" rIns="36720" bIns="18360" anchor="t">
+            <a:spAutoFit/>
+          </a:bodyPr>
+          <a:lstStyle/>
+          <a:p>
+            <a:pPr defTabSz="457200">
+              <a:lnSpc>
+                <a:spcPct val="100000"/>
+              </a:lnSpc>
+            </a:pPr>
+            <a:r>
+              <a:rPr lang="en-US" sz="4000" b="1" dirty="0">
+                <a:solidFill>
+                  <a:srgbClr val="183458"/>
+                </a:solidFill>
+                <a:latin typeface="Calibri"/>
+              </a:rPr>
+              <a:t>BMM-</a:t>
+            </a:r>
+            <a:r>
+              <a:rPr lang="en-US" sz="4000" b="1" dirty="0" err="1">
+                <a:solidFill>
+                  <a:srgbClr val="183458"/>
+                </a:solidFill>
+                <a:latin typeface="Calibri"/>
+              </a:rPr>
+              <a:t>Softmax</a:t>
+            </a:r>
+            <a:r>
+              <a:rPr lang="en-US" sz="4000" b="1" dirty="0">
+                <a:solidFill>
+                  <a:srgbClr val="183458"/>
+                </a:solidFill>
+                <a:latin typeface="Calibri"/>
+              </a:rPr>
+              <a:t>-BMM </a:t>
+            </a:r>
+            <a:r>
+              <a:rPr lang="en-US" sz="4000" b="1" dirty="0" err="1">
+                <a:solidFill>
+                  <a:srgbClr val="183458"/>
+                </a:solidFill>
+                <a:latin typeface="Calibri"/>
+              </a:rPr>
+              <a:t>第二版</a:t>
+            </a:r>
+            <a:endParaRPr lang="en-US" sz="4000" b="0" u="none" strike="noStrike" dirty="0">
+              <a:solidFill>
+                <a:srgbClr val="000000"/>
+              </a:solidFill>
+              <a:effectLst/>
+              <a:uFillTx/>
+              <a:latin typeface="Arial"/>
+            </a:endParaRPr>
+          </a:p>
+        </p:txBody>
+      </p:sp>
+      <p:sp>
+        <p:nvSpPr>
+          <p:cNvPr id="8" name="Rectangle 3">
+            <a:extLst>
+              <a:ext uri="{FF2B5EF4-FFF2-40B4-BE49-F238E27FC236}">
+                <a16:creationId xmlns:a16="http://schemas.microsoft.com/office/drawing/2014/main" id="{0AD8E5B3-1484-137E-5E71-EC2E4738A6BC}"/>
+              </a:ext>
+            </a:extLst>
+          </p:cNvPr>
+          <p:cNvSpPr/>
+          <p:nvPr/>
+        </p:nvSpPr>
+        <p:spPr>
+          <a:xfrm>
+            <a:off x="495480" y="861236"/>
+            <a:ext cx="11201040" cy="27000"/>
+          </a:xfrm>
+          <a:prstGeom prst="rect">
+            <a:avLst/>
+          </a:prstGeom>
+          <a:solidFill>
+            <a:srgbClr val="00897B"/>
+          </a:solidFill>
+          <a:ln>
+            <a:noFill/>
+          </a:ln>
+        </p:spPr>
+        <p:style>
+          <a:lnRef idx="1">
+            <a:schemeClr val="accent1"/>
+          </a:lnRef>
+          <a:fillRef idx="3">
+            <a:schemeClr val="accent1"/>
+          </a:fillRef>
+          <a:effectRef idx="2">
+            <a:schemeClr val="accent1"/>
+          </a:effectRef>
+          <a:fontRef idx="minor"/>
+        </p:style>
+        <p:txBody>
+          <a:bodyPr lIns="36720" tIns="13680" rIns="36720" bIns="13680" anchor="ctr">
+            <a:noAutofit/>
+          </a:bodyPr>
+          <a:lstStyle/>
+          <a:p>
+            <a:endParaRPr lang="en-US" sz="1800" b="0" u="none" strike="noStrike">
+              <a:solidFill>
+                <a:schemeClr val="lt1"/>
+              </a:solidFill>
+              <a:effectLst/>
+              <a:uFillTx/>
+              <a:latin typeface="Calibri"/>
+            </a:endParaRPr>
+          </a:p>
+        </p:txBody>
+      </p:sp>
+      <p:pic>
+        <p:nvPicPr>
+          <p:cNvPr id="5" name="圖片 4">
+            <a:extLst>
+              <a:ext uri="{FF2B5EF4-FFF2-40B4-BE49-F238E27FC236}">
+                <a16:creationId xmlns:a16="http://schemas.microsoft.com/office/drawing/2014/main" id="{38FAF322-7DF7-DF51-679E-FA2DE071E4C4}"/>
+              </a:ext>
+            </a:extLst>
+          </p:cNvPr>
+          <p:cNvPicPr>
+            <a:picLocks noChangeAspect="1"/>
+          </p:cNvPicPr>
+          <p:nvPr/>
+        </p:nvPicPr>
+        <p:blipFill>
+          <a:blip r:embed="rId2"/>
+          <a:stretch>
+            <a:fillRect/>
+          </a:stretch>
+        </p:blipFill>
+        <p:spPr>
+          <a:xfrm>
+            <a:off x="5871709" y="4000273"/>
+            <a:ext cx="5766723" cy="2623367"/>
+          </a:xfrm>
+          <a:prstGeom prst="rect">
+            <a:avLst/>
+          </a:prstGeom>
+        </p:spPr>
+      </p:pic>
+      <p:pic>
+        <p:nvPicPr>
+          <p:cNvPr id="9" name="圖片 8">
+            <a:extLst>
+              <a:ext uri="{FF2B5EF4-FFF2-40B4-BE49-F238E27FC236}">
+                <a16:creationId xmlns:a16="http://schemas.microsoft.com/office/drawing/2014/main" id="{15DF8586-79C0-A1C5-D46C-357F8544DF1B}"/>
+              </a:ext>
+            </a:extLst>
+          </p:cNvPr>
+          <p:cNvPicPr>
+            <a:picLocks noChangeAspect="1"/>
+          </p:cNvPicPr>
+          <p:nvPr/>
+        </p:nvPicPr>
+        <p:blipFill>
+          <a:blip r:embed="rId3"/>
+          <a:stretch>
+            <a:fillRect/>
+          </a:stretch>
+        </p:blipFill>
+        <p:spPr>
+          <a:xfrm>
+            <a:off x="5871710" y="1160810"/>
+            <a:ext cx="5477540" cy="2486954"/>
+          </a:xfrm>
+          <a:prstGeom prst="rect">
+            <a:avLst/>
+          </a:prstGeom>
+        </p:spPr>
+      </p:pic>
+      <p:sp>
+        <p:nvSpPr>
+          <p:cNvPr id="10" name="文字版面配置區 2">
+            <a:extLst>
+              <a:ext uri="{FF2B5EF4-FFF2-40B4-BE49-F238E27FC236}">
+                <a16:creationId xmlns:a16="http://schemas.microsoft.com/office/drawing/2014/main" id="{F361E482-B512-972B-382F-A455286F8727}"/>
+              </a:ext>
+            </a:extLst>
+          </p:cNvPr>
+          <p:cNvSpPr>
+            <a:spLocks noGrp="1"/>
+          </p:cNvSpPr>
+          <p:nvPr>
+            <p:ph type="body"/>
+          </p:nvPr>
+        </p:nvSpPr>
+        <p:spPr>
+          <a:xfrm>
+            <a:off x="423531" y="1147320"/>
+            <a:ext cx="4765158" cy="3055764"/>
+          </a:xfrm>
+        </p:spPr>
+        <p:txBody>
+          <a:bodyPr>
+            <a:normAutofit/>
+          </a:bodyPr>
+          <a:lstStyle/>
+          <a:p>
+            <a:r>
+              <a:rPr lang="zh-TW" altLang="zh-TW" sz="1100" b="1" dirty="0"/>
+              <a:t>MDLA7 profile — bmm_softmax_bmm_tiled_2.5ms_int8.tflite (fast)</a:t>
+            </a:r>
+          </a:p>
+          <a:p>
+            <a:r>
+              <a:rPr lang="zh-TW" altLang="zh-TW" sz="1100" b="1" dirty="0"/>
+              <a:t>Model:</a:t>
+            </a:r>
+            <a:r>
+              <a:rPr lang="zh-TW" altLang="zh-TW" sz="1100" dirty="0"/>
+              <a:t> model/BMM/bmm_softmax_bmm_tiled_2.5ms_int8.tflite</a:t>
+            </a:r>
+            <a:endParaRPr lang="en-US" altLang="zh-TW" sz="1100" dirty="0"/>
+          </a:p>
+          <a:p>
+            <a:r>
+              <a:rPr lang="zh-TW" altLang="zh-TW" sz="1100" b="1" dirty="0"/>
+              <a:t>Compiled layers:</a:t>
+            </a:r>
+            <a:r>
+              <a:rPr lang="zh-TW" altLang="zh-TW" sz="1100" dirty="0"/>
+              <a:t> 1358 (PASS 1358 / FAIL 0)</a:t>
+            </a:r>
+            <a:endParaRPr lang="en-US" altLang="zh-TW" sz="1100" dirty="0"/>
+          </a:p>
+          <a:p>
+            <a:r>
+              <a:rPr lang="zh-TW" altLang="zh-TW" sz="1100" b="1" dirty="0"/>
+              <a:t>Graph coverage: INCOMPLETE — 1/1359 compile rows skipped; simulator PASS covers compiled layers only</a:t>
+            </a:r>
+            <a:endParaRPr lang="en-US" altLang="zh-TW" sz="1100" b="1" dirty="0"/>
+          </a:p>
+          <a:p>
+            <a:r>
+              <a:rPr lang="zh-TW" altLang="zh-TW" sz="1100" b="1" dirty="0"/>
+              <a:t>Verification:</a:t>
+            </a:r>
+            <a:r>
+              <a:rPr lang="zh-TW" altLang="zh-TW" sz="1100" dirty="0"/>
+              <a:t> per compiled-layer DRAM reference compare, including the final compiled layer; no separate original-TFLite final-output checker</a:t>
+            </a:r>
+            <a:endParaRPr lang="en-US" altLang="zh-TW" sz="1100" dirty="0"/>
+          </a:p>
+          <a:p>
+            <a:r>
+              <a:rPr lang="zh-TW" altLang="zh-TW" sz="1100" b="1" dirty="0"/>
+              <a:t>Sim time:</a:t>
+            </a:r>
+            <a:r>
+              <a:rPr lang="zh-TW" altLang="zh-TW" sz="1100" dirty="0"/>
+              <a:t> 11.184 ms @ 1.9 GHz (21,249,675 cycles)</a:t>
+            </a:r>
+            <a:endParaRPr lang="en-US" altLang="zh-TW" sz="1100" dirty="0"/>
+          </a:p>
+          <a:p>
+            <a:r>
+              <a:rPr lang="zh-TW" altLang="zh-TW" sz="1100" b="1" dirty="0"/>
+              <a:t>Util:</a:t>
+            </a:r>
+            <a:r>
+              <a:rPr lang="zh-TW" altLang="zh-TW" sz="1100" dirty="0"/>
+              <a:t> avg 14.0% / peak 62.1% (ewe)</a:t>
+            </a:r>
+            <a:endParaRPr lang="en-US" altLang="zh-TW" sz="1100" dirty="0"/>
+          </a:p>
+          <a:p>
+            <a:r>
+              <a:rPr lang="zh-TW" altLang="zh-TW" sz="1100" b="1" dirty="0"/>
+              <a:t>DRAM r/w:</a:t>
+            </a:r>
+            <a:r>
+              <a:rPr lang="zh-TW" altLang="zh-TW" sz="1100" dirty="0"/>
+              <a:t> 161.30 / 0.00 MB</a:t>
+            </a:r>
+            <a:endParaRPr lang="en-US" altLang="zh-TW" sz="1100" dirty="0"/>
+          </a:p>
+          <a:p>
+            <a:r>
+              <a:rPr lang="zh-TW" altLang="zh-TW" sz="1100" b="1" dirty="0"/>
+              <a:t>SRAM r/w:</a:t>
+            </a:r>
+            <a:r>
+              <a:rPr lang="zh-TW" altLang="zh-TW" sz="1100" dirty="0"/>
+              <a:t> 185.57 / 301.56 MB</a:t>
+            </a:r>
+          </a:p>
+          <a:p>
+            <a:endParaRPr kumimoji="1" lang="zh-TW" altLang="en-US" sz="100" dirty="0"/>
+          </a:p>
+        </p:txBody>
+      </p:sp>
+      <p:pic>
+        <p:nvPicPr>
+          <p:cNvPr id="2" name="圖片 1">
+            <a:extLst>
+              <a:ext uri="{FF2B5EF4-FFF2-40B4-BE49-F238E27FC236}">
+                <a16:creationId xmlns:a16="http://schemas.microsoft.com/office/drawing/2014/main" id="{3A5232E7-29ED-7571-425F-84E4E6C13AD0}"/>
+              </a:ext>
+            </a:extLst>
+          </p:cNvPr>
+          <p:cNvPicPr>
+            <a:picLocks noChangeAspect="1"/>
+          </p:cNvPicPr>
+          <p:nvPr/>
+        </p:nvPicPr>
+        <p:blipFill>
+          <a:blip r:embed="rId4"/>
+          <a:stretch>
+            <a:fillRect/>
+          </a:stretch>
+        </p:blipFill>
+        <p:spPr>
+          <a:xfrm>
+            <a:off x="1550582" y="4000273"/>
+            <a:ext cx="3271610" cy="2486955"/>
+          </a:xfrm>
+          <a:prstGeom prst="rect">
+            <a:avLst/>
+          </a:prstGeom>
+        </p:spPr>
+      </p:pic>
+    </p:spTree>
+    <p:extLst>
+      <p:ext uri="{BB962C8B-B14F-4D97-AF65-F5344CB8AC3E}">
+        <p14:creationId xmlns:p14="http://schemas.microsoft.com/office/powerpoint/2010/main" val="2423405202"/>
+      </p:ext>
+    </p:extLst>
+  </p:cSld>
+  <p:clrMapOvr>
+    <a:masterClrMapping/>
+  </p:clrMapOvr>
+</p:sld>
+</file>
+
 <file path=ppt/slides/slide3.xml><?xml version="1.0" encoding="utf-8"?>
 <p:sld xmlns:a="http://schemas.openxmlformats.org/drawingml/2006/main" xmlns:r="http://schemas.openxmlformats.org/officeDocument/2006/relationships" xmlns:p="http://schemas.openxmlformats.org/presentationml/2006/main">
   <p:cSld>

</xml_diff>